<commit_message>
docs(examples): regenerate the sample deck and add a code-rendered preview
scripts/preview_deck.py draws the five-slide contact sheet from the
actual PPTX text, geometry and chart values, and records the PPTX hash
and rendering method in the PNG metadata.

Co-Authored-By: Claude Opus 5.5 <noreply@anthropic.com>
</commit_message>
<xml_diff>
--- a/docs/examples/sample-deck.pptx
+++ b/docs/examples/sample-deck.pptx
@@ -244,7 +244,7 @@
               <c:strCache>
                 <c:ptCount val="1"/>
                 <c:pt idx="0">
-                  <c:v>Churn by segment</c:v>
+                  <c:v>Weighted monthly churn by segment</c:v>
                 </c:pt>
               </c:strCache>
             </c:strRef>
@@ -801,17 +801,77 @@
           <a:lstStyle/>
           <a:p>
             <a:r>
-              <a:t>f1 · Churn rate · churn_rate_quarter · main.cs.churn_monthly · statement duckdb-5388cc790add · as of 2026-10-16 17:45 UTC</a:t>
-            </a:r>
-          </a:p>
-          <a:p>
-            <a:r>
-              <a:t>f2 · Net revenue retention · nrr_quarter · main.cs.revenue_monthly · statement duckdb-4e74ade4ee1f · as of 2026-10-16 17:45 UTC</a:t>
-            </a:r>
-          </a:p>
-          <a:p>
-            <a:r>
-              <a:t>f3 · Active subscriptions · active_subscriptions · main.cs.churn_monthly · statement duckdb-7bb33ad98091 · as of 2026-10-16 17:45 UTC</a:t>
+              <a:t>f1 · Monthly churn (weighted) · churn_rate_quarter · main.cs.churn_monthly · statement duckdb-eed72c8e07d1 · queried 2026-10-18 04:18 UTC</a:t>
+            </a:r>
+          </a:p>
+          <a:p>
+            <a:r>
+              <a:t>f2 · Monthly NRR (weighted) · nrr_quarter · main.cs.revenue_monthly · statement duckdb-5075d99a6ed2 · queried 2026-10-18 04:18 UTC</a:t>
+            </a:r>
+          </a:p>
+          <a:p>
+            <a:r>
+              <a:t>f3 · Active subscriptions · active_subscriptions · main.cs.churn_monthly · statement duckdb-f73e339fbd2f · queried 2026-10-18 04:18 UTC</a:t>
+            </a:r>
+          </a:p>
+          <a:p>
+            <a:r>
+              <a:t>f1 SQL:</a:t>
+            </a:r>
+          </a:p>
+          <a:p>
+            <a:r>
+              <a:t>SELECT CASE WHEN SUM(active_start) &lt;&gt; 0 THEN SUM(churned) / SUM(active_start) ELSE NULL END AS churn_rate FROM lake.cs.v_churn_monthly__bob WHERE "month" &gt;= $start_month AND "month" &lt; $end_month</a:t>
+            </a:r>
+          </a:p>
+          <a:p>
+            <a:r>
+              <a:t>f1 parameters: {"end_month": "2026-10-01", "start_month": "2026-07-01"}</a:t>
+            </a:r>
+          </a:p>
+          <a:p>
+            <a:r>
+              <a:t>f1 template SHA-256: a897f662afe1919b49268c820e58ea712c28e38f408d7d77465b1debd7053d63</a:t>
+            </a:r>
+          </a:p>
+          <a:p>
+            <a:r>
+              <a:t>f2 SQL:</a:t>
+            </a:r>
+          </a:p>
+          <a:p>
+            <a:r>
+              <a:t>SELECT CASE WHEN SUM(mrr_start) &lt;&gt; 0 THEN SUM(mrr_retained) / SUM(mrr_start) ELSE NULL END AS nrr FROM lake.cs.v_revenue_monthly__bob WHERE "month" &gt;= $start_month AND "month" &lt; $end_month</a:t>
+            </a:r>
+          </a:p>
+          <a:p>
+            <a:r>
+              <a:t>f2 parameters: {"end_month": "2026-10-01", "start_month": "2026-07-01"}</a:t>
+            </a:r>
+          </a:p>
+          <a:p>
+            <a:r>
+              <a:t>f2 template SHA-256: ec85130488823e6392d012cfb710d63468646785670750d0ae22183c9730561a</a:t>
+            </a:r>
+          </a:p>
+          <a:p>
+            <a:r>
+              <a:t>f3 SQL:</a:t>
+            </a:r>
+          </a:p>
+          <a:p>
+            <a:r>
+              <a:t>SELECT SUM(active_start) AS active_subscriptions FROM lake.cs.v_churn_monthly__bob WHERE "month" = $start_month</a:t>
+            </a:r>
+          </a:p>
+          <a:p>
+            <a:r>
+              <a:t>f3 parameters: {"start_month": "2026-07-01"}</a:t>
+            </a:r>
+          </a:p>
+          <a:p>
+            <a:r>
+              <a:t>f3 template SHA-256: 0e1eca481a61ce5a487969e9b73097141164bf4d00f5b0c10955808376a6caaf</a:t>
             </a:r>
           </a:p>
         </p:txBody>
@@ -881,7 +941,27 @@
           <a:lstStyle/>
           <a:p>
             <a:r>
-              <a:t>f4 · Monthly churn · churn_trend_monthly · main.cs.churn_monthly · statement duckdb-e7add026665b · as of 2026-10-16 17:45 UTC</a:t>
+              <a:t>f4 · Monthly churn · churn_trend_monthly · main.cs.churn_monthly · statement duckdb-652fcac2b08a · queried 2026-10-18 04:18 UTC</a:t>
+            </a:r>
+          </a:p>
+          <a:p>
+            <a:r>
+              <a:t>f4 SQL:</a:t>
+            </a:r>
+          </a:p>
+          <a:p>
+            <a:r>
+              <a:t>SELECT STRFTIME(CAST("month" AS TIMESTAMP), '%Y-%m') AS period, CASE WHEN SUM(active_start) &lt;&gt; 0 THEN SUM(churned) / SUM(active_start) ELSE NULL END AS churn_rate FROM lake.cs.v_churn_monthly__bob WHERE "month" &gt;= $start_month AND "month" &lt; $end_month GROUP BY STRFTIME(CAST("month" AS TIMESTAMP), '%Y-%m') ORDER BY period NULLS FIRST</a:t>
+            </a:r>
+          </a:p>
+          <a:p>
+            <a:r>
+              <a:t>f4 parameters: {"end_month": "2026-10-01", "start_month": "2026-07-01"}</a:t>
+            </a:r>
+          </a:p>
+          <a:p>
+            <a:r>
+              <a:t>f4 template SHA-256: a65c9afc5de386b7fa7a0a0e07559acc0c0782b68368b4788443dcc983561b89</a:t>
             </a:r>
           </a:p>
         </p:txBody>
@@ -951,7 +1031,27 @@
           <a:lstStyle/>
           <a:p>
             <a:r>
-              <a:t>f5 · Churn by segment · churn_by_segment · main.cs.churn_monthly · statement duckdb-f9d854e6ef09 · as of 2026-10-16 17:45 UTC</a:t>
+              <a:t>f5 · Weighted monthly churn by segment · churn_by_segment · main.cs.churn_monthly · statement duckdb-f610159e247c · queried 2026-10-18 04:18 UTC</a:t>
+            </a:r>
+          </a:p>
+          <a:p>
+            <a:r>
+              <a:t>f5 SQL:</a:t>
+            </a:r>
+          </a:p>
+          <a:p>
+            <a:r>
+              <a:t>SELECT segment, CASE WHEN SUM(active_start) &lt;&gt; 0 THEN SUM(churned) / SUM(active_start) ELSE NULL END AS churn_rate FROM lake.cs.v_churn_monthly__bob WHERE "month" &gt;= $start_month AND "month" &lt; $end_month GROUP BY segment ORDER BY segment NULLS FIRST</a:t>
+            </a:r>
+          </a:p>
+          <a:p>
+            <a:r>
+              <a:t>f5 parameters: {"end_month": "2026-10-01", "start_month": "2026-07-01"}</a:t>
+            </a:r>
+          </a:p>
+          <a:p>
+            <a:r>
+              <a:t>f5 template SHA-256: 99ee1f03a8e2648a6287d555c03e257b8edeacc38d7f3c16b260ad6e88079e9f</a:t>
             </a:r>
           </a:p>
         </p:txBody>
@@ -1021,27 +1121,127 @@
           <a:lstStyle/>
           <a:p>
             <a:r>
-              <a:t>f1 · Churn rate · churn_rate_quarter · main.cs.churn_monthly · statement duckdb-5388cc790add · as of 2026-10-16 17:45 UTC</a:t>
-            </a:r>
-          </a:p>
-          <a:p>
-            <a:r>
-              <a:t>f2 · Net revenue retention · nrr_quarter · main.cs.revenue_monthly · statement duckdb-4e74ade4ee1f · as of 2026-10-16 17:45 UTC</a:t>
-            </a:r>
-          </a:p>
-          <a:p>
-            <a:r>
-              <a:t>f3 · Active subscriptions · active_subscriptions · main.cs.churn_monthly · statement duckdb-7bb33ad98091 · as of 2026-10-16 17:45 UTC</a:t>
-            </a:r>
-          </a:p>
-          <a:p>
-            <a:r>
-              <a:t>f4 · Monthly churn · churn_trend_monthly · main.cs.churn_monthly · statement duckdb-e7add026665b · as of 2026-10-16 17:45 UTC</a:t>
-            </a:r>
-          </a:p>
-          <a:p>
-            <a:r>
-              <a:t>f5 · Churn by segment · churn_by_segment · main.cs.churn_monthly · statement duckdb-f9d854e6ef09 · as of 2026-10-16 17:45 UTC</a:t>
+              <a:t>f1 · Monthly churn (weighted) · churn_rate_quarter · main.cs.churn_monthly · statement duckdb-eed72c8e07d1 · queried 2026-10-18 04:18 UTC</a:t>
+            </a:r>
+          </a:p>
+          <a:p>
+            <a:r>
+              <a:t>f2 · Monthly NRR (weighted) · nrr_quarter · main.cs.revenue_monthly · statement duckdb-5075d99a6ed2 · queried 2026-10-18 04:18 UTC</a:t>
+            </a:r>
+          </a:p>
+          <a:p>
+            <a:r>
+              <a:t>f3 · Active subscriptions · active_subscriptions · main.cs.churn_monthly · statement duckdb-f73e339fbd2f · queried 2026-10-18 04:18 UTC</a:t>
+            </a:r>
+          </a:p>
+          <a:p>
+            <a:r>
+              <a:t>f4 · Monthly churn · churn_trend_monthly · main.cs.churn_monthly · statement duckdb-652fcac2b08a · queried 2026-10-18 04:18 UTC</a:t>
+            </a:r>
+          </a:p>
+          <a:p>
+            <a:r>
+              <a:t>f5 · Weighted monthly churn by segment · churn_by_segment · main.cs.churn_monthly · statement duckdb-f610159e247c · queried 2026-10-18 04:18 UTC</a:t>
+            </a:r>
+          </a:p>
+          <a:p>
+            <a:r>
+              <a:t>f1 SQL:</a:t>
+            </a:r>
+          </a:p>
+          <a:p>
+            <a:r>
+              <a:t>SELECT CASE WHEN SUM(active_start) &lt;&gt; 0 THEN SUM(churned) / SUM(active_start) ELSE NULL END AS churn_rate FROM lake.cs.v_churn_monthly__bob WHERE "month" &gt;= $start_month AND "month" &lt; $end_month</a:t>
+            </a:r>
+          </a:p>
+          <a:p>
+            <a:r>
+              <a:t>f1 parameters: {"end_month": "2026-10-01", "start_month": "2026-07-01"}</a:t>
+            </a:r>
+          </a:p>
+          <a:p>
+            <a:r>
+              <a:t>f1 template SHA-256: a897f662afe1919b49268c820e58ea712c28e38f408d7d77465b1debd7053d63</a:t>
+            </a:r>
+          </a:p>
+          <a:p>
+            <a:r>
+              <a:t>f2 SQL:</a:t>
+            </a:r>
+          </a:p>
+          <a:p>
+            <a:r>
+              <a:t>SELECT CASE WHEN SUM(mrr_start) &lt;&gt; 0 THEN SUM(mrr_retained) / SUM(mrr_start) ELSE NULL END AS nrr FROM lake.cs.v_revenue_monthly__bob WHERE "month" &gt;= $start_month AND "month" &lt; $end_month</a:t>
+            </a:r>
+          </a:p>
+          <a:p>
+            <a:r>
+              <a:t>f2 parameters: {"end_month": "2026-10-01", "start_month": "2026-07-01"}</a:t>
+            </a:r>
+          </a:p>
+          <a:p>
+            <a:r>
+              <a:t>f2 template SHA-256: ec85130488823e6392d012cfb710d63468646785670750d0ae22183c9730561a</a:t>
+            </a:r>
+          </a:p>
+          <a:p>
+            <a:r>
+              <a:t>f3 SQL:</a:t>
+            </a:r>
+          </a:p>
+          <a:p>
+            <a:r>
+              <a:t>SELECT SUM(active_start) AS active_subscriptions FROM lake.cs.v_churn_monthly__bob WHERE "month" = $start_month</a:t>
+            </a:r>
+          </a:p>
+          <a:p>
+            <a:r>
+              <a:t>f3 parameters: {"start_month": "2026-07-01"}</a:t>
+            </a:r>
+          </a:p>
+          <a:p>
+            <a:r>
+              <a:t>f3 template SHA-256: 0e1eca481a61ce5a487969e9b73097141164bf4d00f5b0c10955808376a6caaf</a:t>
+            </a:r>
+          </a:p>
+          <a:p>
+            <a:r>
+              <a:t>f4 SQL:</a:t>
+            </a:r>
+          </a:p>
+          <a:p>
+            <a:r>
+              <a:t>SELECT STRFTIME(CAST("month" AS TIMESTAMP), '%Y-%m') AS period, CASE WHEN SUM(active_start) &lt;&gt; 0 THEN SUM(churned) / SUM(active_start) ELSE NULL END AS churn_rate FROM lake.cs.v_churn_monthly__bob WHERE "month" &gt;= $start_month AND "month" &lt; $end_month GROUP BY STRFTIME(CAST("month" AS TIMESTAMP), '%Y-%m') ORDER BY period NULLS FIRST</a:t>
+            </a:r>
+          </a:p>
+          <a:p>
+            <a:r>
+              <a:t>f4 parameters: {"end_month": "2026-10-01", "start_month": "2026-07-01"}</a:t>
+            </a:r>
+          </a:p>
+          <a:p>
+            <a:r>
+              <a:t>f4 template SHA-256: a65c9afc5de386b7fa7a0a0e07559acc0c0782b68368b4788443dcc983561b89</a:t>
+            </a:r>
+          </a:p>
+          <a:p>
+            <a:r>
+              <a:t>f5 SQL:</a:t>
+            </a:r>
+          </a:p>
+          <a:p>
+            <a:r>
+              <a:t>SELECT segment, CASE WHEN SUM(active_start) &lt;&gt; 0 THEN SUM(churned) / SUM(active_start) ELSE NULL END AS churn_rate FROM lake.cs.v_churn_monthly__bob WHERE "month" &gt;= $start_month AND "month" &lt; $end_month GROUP BY segment ORDER BY segment NULLS FIRST</a:t>
+            </a:r>
+          </a:p>
+          <a:p>
+            <a:r>
+              <a:t>f5 parameters: {"end_month": "2026-10-01", "start_month": "2026-07-01"}</a:t>
+            </a:r>
+          </a:p>
+          <a:p>
+            <a:r>
+              <a:t>f5 template SHA-256: 99ee1f03a8e2648a6287d555c03e257b8edeacc38d7f3c16b260ad6e88079e9f</a:t>
             </a:r>
           </a:p>
         </p:txBody>
@@ -4158,7 +4358,7 @@
           <a:p>
             <a:r>
               <a:rPr sz="1600"/>
-              <a:t>Churn rate</a:t>
+              <a:t>Monthly churn (weighted)</a:t>
             </a:r>
           </a:p>
         </p:txBody>
@@ -4193,7 +4393,7 @@
           <a:p>
             <a:r>
               <a:rPr sz="1600"/>
-              <a:t>Net revenue retention</a:t>
+              <a:t>Monthly NRR (weighted)</a:t>
             </a:r>
           </a:p>
         </p:txBody>
@@ -4257,7 +4457,7 @@
           <a:p>
             <a:r>
               <a:rPr sz="2000"/>
-              <a:t>Churn reached 2.4% this quarter</a:t>
+              <a:t>Weighted monthly churn was 2.4% over the review period</a:t>
             </a:r>
           </a:p>
         </p:txBody>
@@ -4353,7 +4553,7 @@
           <a:lstStyle/>
           <a:p>
             <a:r>
-              <a:t>Churn by segment</a:t>
+              <a:t>Monthly churn by segment</a:t>
             </a:r>
           </a:p>
         </p:txBody>
@@ -4432,31 +4632,31 @@
           <a:p>
             <a:r>
               <a:rPr sz="1400"/>
-              <a:t>f1 · Churn rate · churn_rate_quarter · main.cs.churn_monthly · statement duckdb-5388cc790add · as of 2026-10-16 17:45 UTC</a:t>
+              <a:t>f1 · Monthly churn (weighted) · churn_rate_quarter · main.cs.churn_monthly · statement duckdb-eed72c8e07d1 · queried 2026-10-18 04:18 UTC</a:t>
             </a:r>
           </a:p>
           <a:p>
             <a:r>
               <a:rPr sz="1400"/>
-              <a:t>f2 · Net revenue retention · nrr_quarter · main.cs.revenue_monthly · statement duckdb-4e74ade4ee1f · as of 2026-10-16 17:45 UTC</a:t>
+              <a:t>f2 · Monthly NRR (weighted) · nrr_quarter · main.cs.revenue_monthly · statement duckdb-5075d99a6ed2 · queried 2026-10-18 04:18 UTC</a:t>
             </a:r>
           </a:p>
           <a:p>
             <a:r>
               <a:rPr sz="1400"/>
-              <a:t>f3 · Active subscriptions · active_subscriptions · main.cs.churn_monthly · statement duckdb-7bb33ad98091 · as of 2026-10-16 17:45 UTC</a:t>
+              <a:t>f3 · Active subscriptions · active_subscriptions · main.cs.churn_monthly · statement duckdb-f73e339fbd2f · queried 2026-10-18 04:18 UTC</a:t>
             </a:r>
           </a:p>
           <a:p>
             <a:r>
               <a:rPr sz="1400"/>
-              <a:t>f4 · Monthly churn · churn_trend_monthly · main.cs.churn_monthly · statement duckdb-e7add026665b · as of 2026-10-16 17:45 UTC</a:t>
+              <a:t>f4 · Monthly churn · churn_trend_monthly · main.cs.churn_monthly · statement duckdb-652fcac2b08a · queried 2026-10-18 04:18 UTC</a:t>
             </a:r>
           </a:p>
           <a:p>
             <a:r>
               <a:rPr sz="1400"/>
-              <a:t>f5 · Churn by segment · churn_by_segment · main.cs.churn_monthly · statement duckdb-f9d854e6ef09 · as of 2026-10-16 17:45 UTC</a:t>
+              <a:t>f5 · Weighted monthly churn by segment · churn_by_segment · main.cs.churn_monthly · statement duckdb-f610159e247c · queried 2026-10-18 04:18 UTC</a:t>
             </a:r>
           </a:p>
         </p:txBody>

</xml_diff>

<commit_message>
feat: give decks a theme, layout registry and consulting-style slides
Replace Office placeholder layouts with painters, design tokens and native
chart styling so a generated deck reads as one argument. Fact provenance,
outline approval and the numeric guardrail stay in place.

Co-authored-by: Santosh Shinde <santoshshinde2012@gmail.com>
</commit_message>
<xml_diff>
--- a/docs/examples/sample-deck.pptx
+++ b/docs/examples/sample-deck.pptx
@@ -11,7 +11,7 @@
     <p:sldId id="259" r:id="rId11"/>
     <p:sldId id="260" r:id="rId12"/>
   </p:sldIdLst>
-  <p:sldSz cx="12191695" cy="6858000" type="screen4x3"/>
+  <p:sldSz cx="12192000" cy="6858000" type="screen4x3"/>
   <p:notesSz cx="6858000" cy="9144000"/>
   <p:defaultTextStyle>
     <a:defPPr>
@@ -115,7 +115,7 @@
 <c:chartSpace xmlns:c="http://schemas.openxmlformats.org/drawingml/2006/chart" xmlns:a="http://schemas.openxmlformats.org/drawingml/2006/main" xmlns:r="http://schemas.openxmlformats.org/officeDocument/2006/relationships">
   <c:date1904 val="0"/>
   <c:chart>
-    <c:autoTitleDeleted val="0"/>
+    <c:autoTitleDeleted val="1"/>
     <c:plotArea>
       <c:lineChart>
         <c:grouping val="standard"/>
@@ -134,6 +134,145 @@
               </c:strCache>
             </c:strRef>
           </c:tx>
+          <c:spPr>
+            <a:ln w="28575">
+              <a:solidFill>
+                <a:srgbClr val="1A3144"/>
+              </a:solidFill>
+            </a:ln>
+          </c:spPr>
+          <c:marker>
+            <c:symbol val="circle"/>
+            <c:size val="8"/>
+            <c:spPr>
+              <a:solidFill>
+                <a:srgbClr val="1A3144"/>
+              </a:solidFill>
+              <a:ln>
+                <a:noFill/>
+              </a:ln>
+            </c:spPr>
+          </c:marker>
+          <c:dPt>
+            <c:idx val="0"/>
+            <c:marker>
+              <c:spPr>
+                <a:solidFill>
+                  <a:srgbClr val="1A3144"/>
+                </a:solidFill>
+                <a:ln>
+                  <a:noFill/>
+                </a:ln>
+              </c:spPr>
+            </c:marker>
+          </c:dPt>
+          <c:dPt>
+            <c:idx val="1"/>
+            <c:marker>
+              <c:spPr>
+                <a:solidFill>
+                  <a:srgbClr val="1A3144"/>
+                </a:solidFill>
+                <a:ln>
+                  <a:noFill/>
+                </a:ln>
+              </c:spPr>
+            </c:marker>
+          </c:dPt>
+          <c:dPt>
+            <c:idx val="2"/>
+            <c:marker>
+              <c:spPr>
+                <a:solidFill>
+                  <a:srgbClr val="9C4221"/>
+                </a:solidFill>
+                <a:ln>
+                  <a:noFill/>
+                </a:ln>
+              </c:spPr>
+            </c:marker>
+          </c:dPt>
+          <c:dLbls>
+            <c:dLbl>
+              <c:idx val="0"/>
+              <c:spPr/>
+              <c:txPr>
+                <a:bodyPr/>
+                <a:lstStyle/>
+                <a:p>
+                  <a:pPr>
+                    <a:defRPr sz="1100" b="0">
+                      <a:solidFill>
+                        <a:srgbClr val="1C1915"/>
+                      </a:solidFill>
+                      <a:latin typeface="Calibri"/>
+                    </a:defRPr>
+                  </a:pPr>
+                </a:p>
+              </c:txPr>
+              <c:showLegendKey val="0"/>
+              <c:showVal val="1"/>
+              <c:showCatName val="0"/>
+              <c:showSerName val="0"/>
+              <c:showPercent val="0"/>
+              <c:showBubbleSize val="0"/>
+            </c:dLbl>
+            <c:dLbl>
+              <c:idx val="1"/>
+              <c:spPr/>
+              <c:txPr>
+                <a:bodyPr/>
+                <a:lstStyle/>
+                <a:p>
+                  <a:pPr>
+                    <a:defRPr sz="1100" b="0">
+                      <a:solidFill>
+                        <a:srgbClr val="1C1915"/>
+                      </a:solidFill>
+                      <a:latin typeface="Calibri"/>
+                    </a:defRPr>
+                  </a:pPr>
+                </a:p>
+              </c:txPr>
+              <c:showLegendKey val="0"/>
+              <c:showVal val="1"/>
+              <c:showCatName val="0"/>
+              <c:showSerName val="0"/>
+              <c:showPercent val="0"/>
+              <c:showBubbleSize val="0"/>
+            </c:dLbl>
+            <c:dLbl>
+              <c:idx val="2"/>
+              <c:spPr/>
+              <c:txPr>
+                <a:bodyPr/>
+                <a:lstStyle/>
+                <a:p>
+                  <a:pPr>
+                    <a:defRPr sz="1200" b="1">
+                      <a:solidFill>
+                        <a:srgbClr val="9C4221"/>
+                      </a:solidFill>
+                      <a:latin typeface="Calibri"/>
+                    </a:defRPr>
+                  </a:pPr>
+                </a:p>
+              </c:txPr>
+              <c:showLegendKey val="0"/>
+              <c:showVal val="1"/>
+              <c:showCatName val="0"/>
+              <c:showSerName val="0"/>
+              <c:showPercent val="0"/>
+              <c:showBubbleSize val="0"/>
+            </c:dLbl>
+            <c:showLegendKey val="0"/>
+            <c:showVal val="0"/>
+            <c:showCatName val="0"/>
+            <c:showSerName val="0"/>
+            <c:showPercent val="0"/>
+            <c:showBubbleSize val="0"/>
+            <c:showLeaderLines val="1"/>
+          </c:dLbls>
           <c:cat>
             <c:strRef>
               <c:f>Sheet1!$A$2:$A$4</c:f>
@@ -171,6 +310,31 @@
           </c:val>
           <c:smooth val="0"/>
         </c:ser>
+        <c:dLbls>
+          <c:numFmt formatCode="0.0%" sourceLinked="0"/>
+          <c:txPr>
+            <a:bodyPr/>
+            <a:lstStyle/>
+            <a:p>
+              <a:pPr>
+                <a:defRPr sz="1100">
+                  <a:solidFill>
+                    <a:srgbClr val="1C1915"/>
+                  </a:solidFill>
+                  <a:latin typeface="Calibri"/>
+                </a:defRPr>
+              </a:pPr>
+            </a:p>
+          </c:txPr>
+          <c:dLblPos val="t"/>
+          <c:showLegendKey val="0"/>
+          <c:showVal val="1"/>
+          <c:showCatName val="0"/>
+          <c:showSerName val="0"/>
+          <c:showPercent val="0"/>
+          <c:showBubbleSize val="0"/>
+          <c:showLeaderLines val="1"/>
+        </c:dLbls>
         <c:marker val="1"/>
         <c:smooth val="0"/>
         <c:axId val="2118791784"/>
@@ -183,9 +347,30 @@
         </c:scaling>
         <c:delete val="0"/>
         <c:axPos val="b"/>
-        <c:majorTickMark val="out"/>
+        <c:majorTickMark val="none"/>
         <c:minorTickMark val="none"/>
         <c:tickLblPos val="nextTo"/>
+        <c:spPr>
+          <a:ln>
+            <a:solidFill>
+              <a:srgbClr val="E3DCD0"/>
+            </a:solidFill>
+          </a:ln>
+        </c:spPr>
+        <c:txPr>
+          <a:bodyPr/>
+          <a:lstStyle/>
+          <a:p>
+            <a:pPr>
+              <a:defRPr sz="1200">
+                <a:solidFill>
+                  <a:srgbClr val="1C1915"/>
+                </a:solidFill>
+                <a:latin typeface="Calibri"/>
+              </a:defRPr>
+            </a:pPr>
+          </a:p>
+        </c:txPr>
         <c:crossAx val="2140495176"/>
         <c:crosses val="autoZero"/>
         <c:auto val="1"/>
@@ -195,13 +380,20 @@
       </c:catAx>
       <c:valAx>
         <c:axId val="2140495176"/>
-        <c:scaling/>
-        <c:delete val="0"/>
+        <c:scaling>
+          <c:max val="0.02562734479891802"/>
+          <c:min val="0.021401826564709563"/>
+        </c:scaling>
+        <c:delete/>
         <c:axPos val="l"/>
-        <c:majorGridlines/>
-        <c:majorTickMark val="out"/>
+        <c:majorTickMark val="none"/>
         <c:minorTickMark val="none"/>
         <c:tickLblPos val="nextTo"/>
+        <c:spPr>
+          <a:ln>
+            <a:noFill/>
+          </a:ln>
+        </c:spPr>
         <c:crossAx val="2118791784"/>
         <c:crosses val="autoZero"/>
       </c:valAx>
@@ -230,11 +422,12 @@
 <c:chartSpace xmlns:c="http://schemas.openxmlformats.org/drawingml/2006/chart" xmlns:a="http://schemas.openxmlformats.org/drawingml/2006/main" xmlns:r="http://schemas.openxmlformats.org/officeDocument/2006/relationships">
   <c:date1904 val="0"/>
   <c:chart>
-    <c:autoTitleDeleted val="0"/>
+    <c:autoTitleDeleted val="1"/>
     <c:plotArea>
       <c:barChart>
         <c:barDir val="bar"/>
         <c:grouping val="clustered"/>
+        <c:varyColors val="0"/>
         <c:ser>
           <c:idx val="0"/>
           <c:order val="0"/>
@@ -249,6 +442,128 @@
               </c:strCache>
             </c:strRef>
           </c:tx>
+          <c:spPr>
+            <a:solidFill>
+              <a:srgbClr val="1A3144"/>
+            </a:solidFill>
+            <a:ln>
+              <a:noFill/>
+            </a:ln>
+          </c:spPr>
+          <c:dPt>
+            <c:idx val="0"/>
+            <c:spPr>
+              <a:solidFill>
+                <a:srgbClr val="1A3144"/>
+              </a:solidFill>
+              <a:ln>
+                <a:noFill/>
+              </a:ln>
+            </c:spPr>
+          </c:dPt>
+          <c:dPt>
+            <c:idx val="1"/>
+            <c:spPr>
+              <a:solidFill>
+                <a:srgbClr val="1A3144"/>
+              </a:solidFill>
+              <a:ln>
+                <a:noFill/>
+              </a:ln>
+            </c:spPr>
+          </c:dPt>
+          <c:dPt>
+            <c:idx val="2"/>
+            <c:spPr>
+              <a:solidFill>
+                <a:srgbClr val="9C4221"/>
+              </a:solidFill>
+              <a:ln>
+                <a:noFill/>
+              </a:ln>
+            </c:spPr>
+          </c:dPt>
+          <c:dLbls>
+            <c:dLbl>
+              <c:idx val="0"/>
+              <c:spPr/>
+              <c:txPr>
+                <a:bodyPr/>
+                <a:lstStyle/>
+                <a:p>
+                  <a:pPr>
+                    <a:defRPr sz="1100" b="0">
+                      <a:solidFill>
+                        <a:srgbClr val="1C1915"/>
+                      </a:solidFill>
+                      <a:latin typeface="Calibri"/>
+                    </a:defRPr>
+                  </a:pPr>
+                </a:p>
+              </c:txPr>
+              <c:showLegendKey val="0"/>
+              <c:showVal val="1"/>
+              <c:showCatName val="0"/>
+              <c:showSerName val="0"/>
+              <c:showPercent val="0"/>
+              <c:showBubbleSize val="0"/>
+            </c:dLbl>
+            <c:dLbl>
+              <c:idx val="1"/>
+              <c:spPr/>
+              <c:txPr>
+                <a:bodyPr/>
+                <a:lstStyle/>
+                <a:p>
+                  <a:pPr>
+                    <a:defRPr sz="1100" b="0">
+                      <a:solidFill>
+                        <a:srgbClr val="1C1915"/>
+                      </a:solidFill>
+                      <a:latin typeface="Calibri"/>
+                    </a:defRPr>
+                  </a:pPr>
+                </a:p>
+              </c:txPr>
+              <c:showLegendKey val="0"/>
+              <c:showVal val="1"/>
+              <c:showCatName val="0"/>
+              <c:showSerName val="0"/>
+              <c:showPercent val="0"/>
+              <c:showBubbleSize val="0"/>
+            </c:dLbl>
+            <c:dLbl>
+              <c:idx val="2"/>
+              <c:spPr/>
+              <c:txPr>
+                <a:bodyPr/>
+                <a:lstStyle/>
+                <a:p>
+                  <a:pPr>
+                    <a:defRPr sz="1200" b="1">
+                      <a:solidFill>
+                        <a:srgbClr val="9C4221"/>
+                      </a:solidFill>
+                      <a:latin typeface="Calibri"/>
+                    </a:defRPr>
+                  </a:pPr>
+                </a:p>
+              </c:txPr>
+              <c:showLegendKey val="0"/>
+              <c:showVal val="1"/>
+              <c:showCatName val="0"/>
+              <c:showSerName val="0"/>
+              <c:showPercent val="0"/>
+              <c:showBubbleSize val="0"/>
+            </c:dLbl>
+            <c:showLegendKey val="0"/>
+            <c:showVal val="0"/>
+            <c:showCatName val="0"/>
+            <c:showSerName val="0"/>
+            <c:showPercent val="0"/>
+            <c:showBubbleSize val="0"/>
+            <c:showLeaderLines val="1"/>
+          </c:dLbls>
           <c:cat>
             <c:strRef>
               <c:f>Sheet1!$A$2:$A$4</c:f>
@@ -285,6 +600,32 @@
             </c:numRef>
           </c:val>
         </c:ser>
+        <c:dLbls>
+          <c:numFmt formatCode="0.0%" sourceLinked="0"/>
+          <c:txPr>
+            <a:bodyPr/>
+            <a:lstStyle/>
+            <a:p>
+              <a:pPr>
+                <a:defRPr sz="1100">
+                  <a:solidFill>
+                    <a:srgbClr val="1C1915"/>
+                  </a:solidFill>
+                  <a:latin typeface="Calibri"/>
+                </a:defRPr>
+              </a:pPr>
+            </a:p>
+          </c:txPr>
+          <c:dLblPos val="r"/>
+          <c:showLegendKey val="0"/>
+          <c:showVal val="1"/>
+          <c:showCatName val="0"/>
+          <c:showSerName val="0"/>
+          <c:showPercent val="0"/>
+          <c:showBubbleSize val="0"/>
+          <c:showLeaderLines val="1"/>
+        </c:dLbls>
+        <c:gapWidth val="80"/>
         <c:axId val="-2068027336"/>
         <c:axId val="-2113994440"/>
       </c:barChart>
@@ -295,9 +636,30 @@
         </c:scaling>
         <c:delete val="0"/>
         <c:axPos val="l"/>
-        <c:majorTickMark val="out"/>
+        <c:majorTickMark val="none"/>
         <c:minorTickMark val="none"/>
         <c:tickLblPos val="nextTo"/>
+        <c:spPr>
+          <a:ln>
+            <a:solidFill>
+              <a:srgbClr val="E3DCD0"/>
+            </a:solidFill>
+          </a:ln>
+        </c:spPr>
+        <c:txPr>
+          <a:bodyPr/>
+          <a:lstStyle/>
+          <a:p>
+            <a:pPr>
+              <a:defRPr sz="1200">
+                <a:solidFill>
+                  <a:srgbClr val="1C1915"/>
+                </a:solidFill>
+                <a:latin typeface="Calibri"/>
+              </a:defRPr>
+            </a:pPr>
+          </a:p>
+        </c:txPr>
         <c:crossAx val="-2113994440"/>
         <c:crosses val="autoZero"/>
         <c:auto val="1"/>
@@ -307,13 +669,20 @@
       </c:catAx>
       <c:valAx>
         <c:axId val="-2113994440"/>
-        <c:scaling/>
-        <c:delete val="0"/>
+        <c:scaling>
+          <c:max val="0.04052836052836053"/>
+          <c:min val="0.0"/>
+        </c:scaling>
+        <c:delete/>
         <c:axPos val="b"/>
-        <c:majorGridlines/>
-        <c:majorTickMark val="out"/>
+        <c:majorTickMark val="none"/>
         <c:minorTickMark val="none"/>
         <c:tickLblPos val="nextTo"/>
+        <c:spPr>
+          <a:ln>
+            <a:noFill/>
+          </a:ln>
+        </c:spPr>
         <c:crossAx val="-2068027336"/>
         <c:crosses val="autoZero"/>
       </c:valAx>
@@ -801,17 +1170,17 @@
           <a:lstStyle/>
           <a:p>
             <a:r>
-              <a:t>f1 · Monthly churn (weighted) · churn_rate_quarter · main.cs.churn_monthly · statement duckdb-eed72c8e07d1 · queried 2026-10-18 04:18 UTC</a:t>
-            </a:r>
-          </a:p>
-          <a:p>
-            <a:r>
-              <a:t>f2 · Monthly NRR (weighted) · nrr_quarter · main.cs.revenue_monthly · statement duckdb-5075d99a6ed2 · queried 2026-10-18 04:18 UTC</a:t>
-            </a:r>
-          </a:p>
-          <a:p>
-            <a:r>
-              <a:t>f3 · Active subscriptions · active_subscriptions · main.cs.churn_monthly · statement duckdb-f73e339fbd2f · queried 2026-10-18 04:18 UTC</a:t>
+              <a:t>f1 · Monthly churn (weighted) · churn_rate_quarter · main.cs.churn_monthly · statement duckdb-340e134303f9 · queried 2026-10-18 07:24 UTC</a:t>
+            </a:r>
+          </a:p>
+          <a:p>
+            <a:r>
+              <a:t>f2 · Monthly NRR (weighted) · nrr_quarter · main.cs.revenue_monthly · statement duckdb-b591257632fc · queried 2026-10-18 07:24 UTC</a:t>
+            </a:r>
+          </a:p>
+          <a:p>
+            <a:r>
+              <a:t>f3 · Active subscriptions · active_subscriptions · main.cs.churn_monthly · statement duckdb-e8b898c41384 · queried 2026-10-18 07:24 UTC</a:t>
             </a:r>
           </a:p>
           <a:p>
@@ -941,7 +1310,7 @@
           <a:lstStyle/>
           <a:p>
             <a:r>
-              <a:t>f4 · Monthly churn · churn_trend_monthly · main.cs.churn_monthly · statement duckdb-652fcac2b08a · queried 2026-10-18 04:18 UTC</a:t>
+              <a:t>f4 · Monthly churn · churn_trend_monthly · main.cs.churn_monthly · statement duckdb-a0f80dfe22cb · queried 2026-10-18 07:24 UTC</a:t>
             </a:r>
           </a:p>
           <a:p>
@@ -1031,7 +1400,7 @@
           <a:lstStyle/>
           <a:p>
             <a:r>
-              <a:t>f5 · Weighted monthly churn by segment · churn_by_segment · main.cs.churn_monthly · statement duckdb-f610159e247c · queried 2026-10-18 04:18 UTC</a:t>
+              <a:t>f5 · Weighted monthly churn by segment · churn_by_segment · main.cs.churn_monthly · statement duckdb-1b44996c3695 · queried 2026-10-18 07:24 UTC</a:t>
             </a:r>
           </a:p>
           <a:p>
@@ -1121,27 +1490,27 @@
           <a:lstStyle/>
           <a:p>
             <a:r>
-              <a:t>f1 · Monthly churn (weighted) · churn_rate_quarter · main.cs.churn_monthly · statement duckdb-eed72c8e07d1 · queried 2026-10-18 04:18 UTC</a:t>
-            </a:r>
-          </a:p>
-          <a:p>
-            <a:r>
-              <a:t>f2 · Monthly NRR (weighted) · nrr_quarter · main.cs.revenue_monthly · statement duckdb-5075d99a6ed2 · queried 2026-10-18 04:18 UTC</a:t>
-            </a:r>
-          </a:p>
-          <a:p>
-            <a:r>
-              <a:t>f3 · Active subscriptions · active_subscriptions · main.cs.churn_monthly · statement duckdb-f73e339fbd2f · queried 2026-10-18 04:18 UTC</a:t>
-            </a:r>
-          </a:p>
-          <a:p>
-            <a:r>
-              <a:t>f4 · Monthly churn · churn_trend_monthly · main.cs.churn_monthly · statement duckdb-652fcac2b08a · queried 2026-10-18 04:18 UTC</a:t>
-            </a:r>
-          </a:p>
-          <a:p>
-            <a:r>
-              <a:t>f5 · Weighted monthly churn by segment · churn_by_segment · main.cs.churn_monthly · statement duckdb-f610159e247c · queried 2026-10-18 04:18 UTC</a:t>
+              <a:t>f1 · Monthly churn (weighted) · churn_rate_quarter · main.cs.churn_monthly · statement duckdb-340e134303f9 · queried 2026-10-18 07:24 UTC</a:t>
+            </a:r>
+          </a:p>
+          <a:p>
+            <a:r>
+              <a:t>f2 · Monthly NRR (weighted) · nrr_quarter · main.cs.revenue_monthly · statement duckdb-b591257632fc · queried 2026-10-18 07:24 UTC</a:t>
+            </a:r>
+          </a:p>
+          <a:p>
+            <a:r>
+              <a:t>f3 · Active subscriptions · active_subscriptions · main.cs.churn_monthly · statement duckdb-e8b898c41384 · queried 2026-10-18 07:24 UTC</a:t>
+            </a:r>
+          </a:p>
+          <a:p>
+            <a:r>
+              <a:t>f4 · Monthly churn · churn_trend_monthly · main.cs.churn_monthly · statement duckdb-a0f80dfe22cb · queried 2026-10-18 07:24 UTC</a:t>
+            </a:r>
+          </a:p>
+          <a:p>
+            <a:r>
+              <a:t>f5 · Weighted monthly churn by segment · churn_by_segment · main.cs.churn_monthly · statement duckdb-1b44996c3695 · queried 2026-10-18 07:24 UTC</a:t>
             </a:r>
           </a:p>
           <a:p>
@@ -4240,6 +4609,14 @@
 <file path=ppt/slides/slide1.xml><?xml version="1.0" encoding="utf-8"?>
 <p:sld xmlns:a="http://schemas.openxmlformats.org/drawingml/2006/main" xmlns:p="http://schemas.openxmlformats.org/presentationml/2006/main" xmlns:r="http://schemas.openxmlformats.org/officeDocument/2006/relationships">
   <p:cSld>
+    <p:bg>
+      <p:bgPr>
+        <a:solidFill>
+          <a:srgbClr val="1A3144"/>
+        </a:solidFill>
+        <a:effectLst/>
+      </p:bgPr>
+    </p:bg>
     <p:spTree>
       <p:nvGrpSpPr>
         <p:cNvPr id="1" name=""/>
@@ -4249,42 +4626,323 @@
       <p:grpSpPr/>
       <p:sp>
         <p:nvSpPr>
-          <p:cNvPr id="2" name="Title 1"/>
-          <p:cNvSpPr>
-            <a:spLocks noGrp="1"/>
-          </p:cNvSpPr>
-          <p:nvPr>
-            <p:ph type="ctrTitle"/>
-          </p:nvPr>
-        </p:nvSpPr>
-        <p:spPr/>
-        <p:txBody>
-          <a:bodyPr/>
-          <a:lstStyle/>
-          <a:p>
-            <a:r>
-              <a:t>Customer retention review</a:t>
-            </a:r>
-          </a:p>
-        </p:txBody>
-      </p:sp>
-      <p:sp>
-        <p:nvSpPr>
-          <p:cNvPr id="3" name="Subtitle 2"/>
-          <p:cNvSpPr>
-            <a:spLocks noGrp="1"/>
-          </p:cNvSpPr>
-          <p:nvPr>
-            <p:ph type="subTitle" idx="1"/>
-          </p:nvPr>
-        </p:nvSpPr>
-        <p:spPr/>
-        <p:txBody>
-          <a:bodyPr/>
-          <a:lstStyle/>
-          <a:p>
-            <a:r>
+          <p:cNvPr id="2" name="Rectangle 1"/>
+          <p:cNvSpPr/>
+          <p:nvPr/>
+        </p:nvSpPr>
+        <p:spPr>
+          <a:xfrm>
+            <a:off x="7071359" y="0"/>
+            <a:ext cx="5120641" cy="6858000"/>
+          </a:xfrm>
+          <a:prstGeom prst="rect">
+            <a:avLst/>
+          </a:prstGeom>
+          <a:solidFill>
+            <a:srgbClr val="F4F0E8"/>
+          </a:solidFill>
+          <a:ln>
+            <a:noFill/>
+          </a:ln>
+        </p:spPr>
+        <p:style>
+          <a:lnRef idx="1">
+            <a:schemeClr val="accent1"/>
+          </a:lnRef>
+          <a:fillRef idx="3">
+            <a:schemeClr val="accent1"/>
+          </a:fillRef>
+          <a:effectRef idx="2">
+            <a:schemeClr val="accent1"/>
+          </a:effectRef>
+          <a:fontRef idx="minor">
+            <a:schemeClr val="lt1"/>
+          </a:fontRef>
+        </p:style>
+        <p:txBody>
+          <a:bodyPr rtlCol="0" anchor="ctr"/>
+          <a:lstStyle/>
+          <a:p>
+            <a:pPr algn="ctr"/>
+          </a:p>
+        </p:txBody>
+      </p:sp>
+      <p:sp>
+        <p:nvSpPr>
+          <p:cNvPr id="3" name="Rectangle 2"/>
+          <p:cNvSpPr/>
+          <p:nvPr/>
+        </p:nvSpPr>
+        <p:spPr>
+          <a:xfrm>
+            <a:off x="7016495" y="0"/>
+            <a:ext cx="54864" cy="6858000"/>
+          </a:xfrm>
+          <a:prstGeom prst="rect">
+            <a:avLst/>
+          </a:prstGeom>
+          <a:solidFill>
+            <a:srgbClr val="9C4221"/>
+          </a:solidFill>
+          <a:ln>
+            <a:noFill/>
+          </a:ln>
+        </p:spPr>
+        <p:style>
+          <a:lnRef idx="1">
+            <a:schemeClr val="accent1"/>
+          </a:lnRef>
+          <a:fillRef idx="3">
+            <a:schemeClr val="accent1"/>
+          </a:fillRef>
+          <a:effectRef idx="2">
+            <a:schemeClr val="accent1"/>
+          </a:effectRef>
+          <a:fontRef idx="minor">
+            <a:schemeClr val="lt1"/>
+          </a:fontRef>
+        </p:style>
+        <p:txBody>
+          <a:bodyPr rtlCol="0" anchor="ctr"/>
+          <a:lstStyle/>
+          <a:p>
+            <a:pPr algn="ctr"/>
+          </a:p>
+        </p:txBody>
+      </p:sp>
+      <p:sp>
+        <p:nvSpPr>
+          <p:cNvPr id="4" name="TextBox 3"/>
+          <p:cNvSpPr txBox="1"/>
+          <p:nvPr/>
+        </p:nvSpPr>
+        <p:spPr>
+          <a:xfrm>
+            <a:off x="566928" y="6035040"/>
+            <a:ext cx="1828800" cy="274320"/>
+          </a:xfrm>
+          <a:prstGeom prst="rect">
+            <a:avLst/>
+          </a:prstGeom>
+          <a:noFill/>
+        </p:spPr>
+        <p:txBody>
+          <a:bodyPr wrap="square" lIns="0" rIns="0" tIns="0" bIns="0" anchor="t"/>
+          <a:lstStyle/>
+          <a:p>
+            <a:pPr algn="l">
+              <a:lnSpc>
+                <a:spcPct val="100000"/>
+              </a:lnSpc>
+              <a:spcBef>
+                <a:spcPts val="0"/>
+              </a:spcBef>
+              <a:spcAft>
+                <a:spcPts val="0"/>
+              </a:spcAft>
+            </a:pPr>
+            <a:r>
+              <a:rPr sz="1200" b="0">
+                <a:solidFill>
+                  <a:srgbClr val="C5D0D6"/>
+                </a:solidFill>
+                <a:latin typeface="Calibri"/>
+              </a:rPr>
+              <a:t>DeckSmith</a:t>
+            </a:r>
+          </a:p>
+        </p:txBody>
+      </p:sp>
+      <p:sp>
+        <p:nvSpPr>
+          <p:cNvPr id="5" name="TextBox 4"/>
+          <p:cNvSpPr txBox="1"/>
+          <p:nvPr/>
+        </p:nvSpPr>
+        <p:spPr>
+          <a:xfrm>
+            <a:off x="566928" y="2057400"/>
+            <a:ext cx="6367271" cy="2011680"/>
+          </a:xfrm>
+          <a:prstGeom prst="rect">
+            <a:avLst/>
+          </a:prstGeom>
+          <a:noFill/>
+        </p:spPr>
+        <p:txBody>
+          <a:bodyPr wrap="square" lIns="0" rIns="0" tIns="0" bIns="0" anchor="t"/>
+          <a:lstStyle/>
+          <a:p>
+            <a:pPr algn="l">
+              <a:lnSpc>
+                <a:spcPct val="100000"/>
+              </a:lnSpc>
+              <a:spcBef>
+                <a:spcPts val="0"/>
+              </a:spcBef>
+              <a:spcAft>
+                <a:spcPts val="0"/>
+              </a:spcAft>
+            </a:pPr>
+            <a:r>
+              <a:rPr sz="4400" b="0">
+                <a:solidFill>
+                  <a:srgbClr val="F4F0E8"/>
+                </a:solidFill>
+                <a:latin typeface="Georgia"/>
+              </a:rPr>
+              <a:t>Customer retention</a:t>
+            </a:r>
+          </a:p>
+          <a:p>
+            <a:pPr algn="l">
+              <a:lnSpc>
+                <a:spcPct val="100000"/>
+              </a:lnSpc>
+              <a:spcBef>
+                <a:spcPts val="0"/>
+              </a:spcBef>
+              <a:spcAft>
+                <a:spcPts val="0"/>
+              </a:spcAft>
+            </a:pPr>
+            <a:r>
+              <a:rPr sz="4400" b="0">
+                <a:solidFill>
+                  <a:srgbClr val="F4F0E8"/>
+                </a:solidFill>
+                <a:latin typeface="Georgia"/>
+              </a:rPr>
+              <a:t>review</a:t>
+            </a:r>
+          </a:p>
+        </p:txBody>
+      </p:sp>
+      <p:sp>
+        <p:nvSpPr>
+          <p:cNvPr id="6" name="TextBox 5"/>
+          <p:cNvSpPr txBox="1"/>
+          <p:nvPr/>
+        </p:nvSpPr>
+        <p:spPr>
+          <a:xfrm>
+            <a:off x="566928" y="4160520"/>
+            <a:ext cx="6367271" cy="731520"/>
+          </a:xfrm>
+          <a:prstGeom prst="rect">
+            <a:avLst/>
+          </a:prstGeom>
+          <a:noFill/>
+        </p:spPr>
+        <p:txBody>
+          <a:bodyPr wrap="square" lIns="0" rIns="0" tIns="0" bIns="0" anchor="t"/>
+          <a:lstStyle/>
+          <a:p>
+            <a:pPr algn="l">
+              <a:lnSpc>
+                <a:spcPct val="100000"/>
+              </a:lnSpc>
+              <a:spcBef>
+                <a:spcPts val="0"/>
+              </a:spcBef>
+              <a:spcAft>
+                <a:spcPts val="0"/>
+              </a:spcAft>
+            </a:pPr>
+            <a:r>
+              <a:rPr sz="1800" b="0">
+                <a:solidFill>
+                  <a:srgbClr val="C5D0D6"/>
+                </a:solidFill>
+                <a:latin typeface="Calibri"/>
+              </a:rPr>
               <a:t>Prepared for the exec audience</a:t>
+            </a:r>
+          </a:p>
+        </p:txBody>
+      </p:sp>
+      <p:sp>
+        <p:nvSpPr>
+          <p:cNvPr id="7" name="Oval 6"/>
+          <p:cNvSpPr/>
+          <p:nvPr/>
+        </p:nvSpPr>
+        <p:spPr>
+          <a:xfrm>
+            <a:off x="8808719" y="2606040"/>
+            <a:ext cx="1645920" cy="1645920"/>
+          </a:xfrm>
+          <a:prstGeom prst="ellipse">
+            <a:avLst/>
+          </a:prstGeom>
+          <a:noFill/>
+          <a:ln w="15875">
+            <a:solidFill>
+              <a:srgbClr val="9C4221"/>
+            </a:solidFill>
+          </a:ln>
+        </p:spPr>
+        <p:style>
+          <a:lnRef idx="1">
+            <a:schemeClr val="accent1"/>
+          </a:lnRef>
+          <a:fillRef idx="3">
+            <a:schemeClr val="accent1"/>
+          </a:fillRef>
+          <a:effectRef idx="2">
+            <a:schemeClr val="accent1"/>
+          </a:effectRef>
+          <a:fontRef idx="minor">
+            <a:schemeClr val="lt1"/>
+          </a:fontRef>
+        </p:style>
+        <p:txBody>
+          <a:bodyPr rtlCol="0" anchor="ctr"/>
+          <a:lstStyle/>
+          <a:p>
+            <a:pPr algn="ctr"/>
+          </a:p>
+        </p:txBody>
+      </p:sp>
+      <p:sp>
+        <p:nvSpPr>
+          <p:cNvPr id="8" name="TextBox 7"/>
+          <p:cNvSpPr txBox="1"/>
+          <p:nvPr/>
+        </p:nvSpPr>
+        <p:spPr>
+          <a:xfrm>
+            <a:off x="5864351" y="6483096"/>
+            <a:ext cx="640080" cy="292608"/>
+          </a:xfrm>
+          <a:prstGeom prst="rect">
+            <a:avLst/>
+          </a:prstGeom>
+          <a:noFill/>
+        </p:spPr>
+        <p:txBody>
+          <a:bodyPr wrap="square" lIns="0" rIns="0" tIns="0" bIns="0" anchor="t"/>
+          <a:lstStyle/>
+          <a:p>
+            <a:pPr algn="r">
+              <a:lnSpc>
+                <a:spcPct val="100000"/>
+              </a:lnSpc>
+              <a:spcBef>
+                <a:spcPts val="0"/>
+              </a:spcBef>
+              <a:spcAft>
+                <a:spcPts val="0"/>
+              </a:spcAft>
+            </a:pPr>
+            <a:r>
+              <a:rPr sz="1300" b="0">
+                <a:solidFill>
+                  <a:srgbClr val="F4F0E8"/>
+                </a:solidFill>
+                <a:latin typeface="Georgia"/>
+              </a:rPr>
+              <a:t>I</a:t>
             </a:r>
           </a:p>
         </p:txBody>
@@ -4300,6 +4958,14 @@
 <file path=ppt/slides/slide2.xml><?xml version="1.0" encoding="utf-8"?>
 <p:sld xmlns:a="http://schemas.openxmlformats.org/drawingml/2006/main" xmlns:p="http://schemas.openxmlformats.org/presentationml/2006/main" xmlns:r="http://schemas.openxmlformats.org/officeDocument/2006/relationships">
   <p:cSld>
+    <p:bg>
+      <p:bgPr>
+        <a:solidFill>
+          <a:srgbClr val="F4F0E8"/>
+        </a:solidFill>
+        <a:effectLst/>
+      </p:bgPr>
+    </p:bg>
     <p:spTree>
       <p:nvGrpSpPr>
         <p:cNvPr id="1" name=""/>
@@ -4309,35 +4975,14 @@
       <p:grpSpPr/>
       <p:sp>
         <p:nvSpPr>
-          <p:cNvPr id="2" name="Title 1"/>
-          <p:cNvSpPr>
-            <a:spLocks noGrp="1"/>
-          </p:cNvSpPr>
-          <p:nvPr>
-            <p:ph type="title"/>
-          </p:nvPr>
-        </p:nvSpPr>
-        <p:spPr/>
-        <p:txBody>
-          <a:bodyPr/>
-          <a:lstStyle/>
-          <a:p>
-            <a:r>
-              <a:t>Retention at a glance</a:t>
-            </a:r>
-          </a:p>
-        </p:txBody>
-      </p:sp>
-      <p:sp>
-        <p:nvSpPr>
-          <p:cNvPr id="3" name="TextBox 2"/>
+          <p:cNvPr id="2" name="TextBox 1"/>
           <p:cNvSpPr txBox="1"/>
           <p:nvPr/>
         </p:nvSpPr>
         <p:spPr>
           <a:xfrm>
-            <a:off x="731520" y="1828800"/>
-            <a:ext cx="3393338" cy="2011680"/>
+            <a:off x="566928" y="347472"/>
+            <a:ext cx="11058144" cy="841248"/>
           </a:xfrm>
           <a:prstGeom prst="rect">
             <a:avLst/>
@@ -4345,34 +4990,173 @@
           <a:noFill/>
         </p:spPr>
         <p:txBody>
-          <a:bodyPr wrap="none">
-            <a:spAutoFit/>
-          </a:bodyPr>
-          <a:lstStyle/>
-          <a:p>
-            <a:r>
-              <a:rPr sz="4000" b="1"/>
-              <a:t>2.4%</a:t>
-            </a:r>
-          </a:p>
-          <a:p>
-            <a:r>
-              <a:rPr sz="1600"/>
-              <a:t>Monthly churn (weighted)</a:t>
-            </a:r>
-          </a:p>
-        </p:txBody>
-      </p:sp>
-      <p:sp>
-        <p:nvSpPr>
-          <p:cNvPr id="4" name="TextBox 3"/>
+          <a:bodyPr wrap="square" lIns="0" rIns="0" tIns="0" bIns="0" anchor="b"/>
+          <a:lstStyle/>
+          <a:p>
+            <a:pPr algn="l">
+              <a:lnSpc>
+                <a:spcPct val="100000"/>
+              </a:lnSpc>
+              <a:spcBef>
+                <a:spcPts val="0"/>
+              </a:spcBef>
+              <a:spcAft>
+                <a:spcPts val="0"/>
+              </a:spcAft>
+            </a:pPr>
+            <a:r>
+              <a:rPr sz="2800" b="0">
+                <a:solidFill>
+                  <a:srgbClr val="1C1915"/>
+                </a:solidFill>
+                <a:latin typeface="Georgia"/>
+              </a:rPr>
+              <a:t>Where retention stands</a:t>
+            </a:r>
+          </a:p>
+        </p:txBody>
+      </p:sp>
+      <p:sp>
+        <p:nvSpPr>
+          <p:cNvPr id="3" name="Rectangle 2"/>
+          <p:cNvSpPr/>
+          <p:nvPr/>
+        </p:nvSpPr>
+        <p:spPr>
+          <a:xfrm>
+            <a:off x="566928" y="1234440"/>
+            <a:ext cx="365760" cy="27432"/>
+          </a:xfrm>
+          <a:prstGeom prst="rect">
+            <a:avLst/>
+          </a:prstGeom>
+          <a:solidFill>
+            <a:srgbClr val="9C4221"/>
+          </a:solidFill>
+          <a:ln>
+            <a:noFill/>
+          </a:ln>
+        </p:spPr>
+        <p:style>
+          <a:lnRef idx="1">
+            <a:schemeClr val="accent1"/>
+          </a:lnRef>
+          <a:fillRef idx="3">
+            <a:schemeClr val="accent1"/>
+          </a:fillRef>
+          <a:effectRef idx="2">
+            <a:schemeClr val="accent1"/>
+          </a:effectRef>
+          <a:fontRef idx="minor">
+            <a:schemeClr val="lt1"/>
+          </a:fontRef>
+        </p:style>
+        <p:txBody>
+          <a:bodyPr rtlCol="0" anchor="ctr"/>
+          <a:lstStyle/>
+          <a:p>
+            <a:pPr algn="ctr"/>
+          </a:p>
+        </p:txBody>
+      </p:sp>
+      <p:sp>
+        <p:nvSpPr>
+          <p:cNvPr id="4" name="Rounded Rectangle 3"/>
+          <p:cNvSpPr/>
+          <p:nvPr/>
+        </p:nvSpPr>
+        <p:spPr>
+          <a:xfrm>
+            <a:off x="566928" y="1463040"/>
+            <a:ext cx="3740912" cy="2057400"/>
+          </a:xfrm>
+          <a:prstGeom prst="roundRect">
+            <a:avLst>
+              <a:gd name="adj" fmla="val 8000"/>
+            </a:avLst>
+          </a:prstGeom>
+          <a:solidFill>
+            <a:srgbClr val="FBF9F5"/>
+          </a:solidFill>
+          <a:ln>
+            <a:noFill/>
+          </a:ln>
+        </p:spPr>
+        <p:style>
+          <a:lnRef idx="1">
+            <a:schemeClr val="accent1"/>
+          </a:lnRef>
+          <a:fillRef idx="3">
+            <a:schemeClr val="accent1"/>
+          </a:fillRef>
+          <a:effectRef idx="2">
+            <a:schemeClr val="accent1"/>
+          </a:effectRef>
+          <a:fontRef idx="minor">
+            <a:schemeClr val="lt1"/>
+          </a:fontRef>
+        </p:style>
+        <p:txBody>
+          <a:bodyPr rtlCol="0" anchor="ctr"/>
+          <a:lstStyle/>
+          <a:p>
+            <a:pPr algn="ctr"/>
+          </a:p>
+        </p:txBody>
+      </p:sp>
+      <p:sp>
+        <p:nvSpPr>
+          <p:cNvPr id="5" name="Rectangle 4"/>
+          <p:cNvSpPr/>
+          <p:nvPr/>
+        </p:nvSpPr>
+        <p:spPr>
+          <a:xfrm>
+            <a:off x="566928" y="1463040"/>
+            <a:ext cx="3740912" cy="36576"/>
+          </a:xfrm>
+          <a:prstGeom prst="rect">
+            <a:avLst/>
+          </a:prstGeom>
+          <a:solidFill>
+            <a:srgbClr val="9C4221"/>
+          </a:solidFill>
+          <a:ln>
+            <a:noFill/>
+          </a:ln>
+        </p:spPr>
+        <p:style>
+          <a:lnRef idx="1">
+            <a:schemeClr val="accent1"/>
+          </a:lnRef>
+          <a:fillRef idx="3">
+            <a:schemeClr val="accent1"/>
+          </a:fillRef>
+          <a:effectRef idx="2">
+            <a:schemeClr val="accent1"/>
+          </a:effectRef>
+          <a:fontRef idx="minor">
+            <a:schemeClr val="lt1"/>
+          </a:fontRef>
+        </p:style>
+        <p:txBody>
+          <a:bodyPr rtlCol="0" anchor="ctr"/>
+          <a:lstStyle/>
+          <a:p>
+            <a:pPr algn="ctr"/>
+          </a:p>
+        </p:txBody>
+      </p:sp>
+      <p:sp>
+        <p:nvSpPr>
+          <p:cNvPr id="6" name="TextBox 5"/>
           <p:cNvSpPr txBox="1"/>
           <p:nvPr/>
         </p:nvSpPr>
         <p:spPr>
           <a:xfrm>
-            <a:off x="4399178" y="1828800"/>
-            <a:ext cx="3393338" cy="2011680"/>
+            <a:off x="704088" y="1691640"/>
+            <a:ext cx="3512312" cy="822960"/>
           </a:xfrm>
           <a:prstGeom prst="rect">
             <a:avLst/>
@@ -4380,34 +5164,42 @@
           <a:noFill/>
         </p:spPr>
         <p:txBody>
-          <a:bodyPr wrap="none">
-            <a:spAutoFit/>
-          </a:bodyPr>
-          <a:lstStyle/>
-          <a:p>
-            <a:r>
-              <a:rPr sz="4000" b="1"/>
-              <a:t>99.8%</a:t>
-            </a:r>
-          </a:p>
-          <a:p>
-            <a:r>
-              <a:rPr sz="1600"/>
-              <a:t>Monthly NRR (weighted)</a:t>
-            </a:r>
-          </a:p>
-        </p:txBody>
-      </p:sp>
-      <p:sp>
-        <p:nvSpPr>
-          <p:cNvPr id="5" name="TextBox 4"/>
+          <a:bodyPr wrap="square" lIns="0" rIns="0" tIns="0" bIns="0" anchor="ctr"/>
+          <a:lstStyle/>
+          <a:p>
+            <a:pPr algn="l">
+              <a:lnSpc>
+                <a:spcPct val="100000"/>
+              </a:lnSpc>
+              <a:spcBef>
+                <a:spcPts val="0"/>
+              </a:spcBef>
+              <a:spcAft>
+                <a:spcPts val="0"/>
+              </a:spcAft>
+            </a:pPr>
+            <a:r>
+              <a:rPr sz="4000" b="1">
+                <a:solidFill>
+                  <a:srgbClr val="1C1915"/>
+                </a:solidFill>
+                <a:latin typeface="Georgia"/>
+              </a:rPr>
+              <a:t>2.4%</a:t>
+            </a:r>
+          </a:p>
+        </p:txBody>
+      </p:sp>
+      <p:sp>
+        <p:nvSpPr>
+          <p:cNvPr id="7" name="TextBox 6"/>
           <p:cNvSpPr txBox="1"/>
           <p:nvPr/>
         </p:nvSpPr>
         <p:spPr>
           <a:xfrm>
-            <a:off x="8066836" y="1828800"/>
-            <a:ext cx="3393338" cy="2011680"/>
+            <a:off x="704088" y="2560320"/>
+            <a:ext cx="3512312" cy="640080"/>
           </a:xfrm>
           <a:prstGeom prst="rect">
             <a:avLst/>
@@ -4415,34 +5207,130 @@
           <a:noFill/>
         </p:spPr>
         <p:txBody>
-          <a:bodyPr wrap="none">
-            <a:spAutoFit/>
-          </a:bodyPr>
-          <a:lstStyle/>
-          <a:p>
-            <a:r>
-              <a:rPr sz="4000" b="1"/>
-              <a:t>6,172</a:t>
-            </a:r>
-          </a:p>
-          <a:p>
-            <a:r>
-              <a:rPr sz="1600"/>
-              <a:t>Active subscriptions</a:t>
-            </a:r>
-          </a:p>
-        </p:txBody>
-      </p:sp>
-      <p:sp>
-        <p:nvSpPr>
-          <p:cNvPr id="6" name="TextBox 5"/>
+          <a:bodyPr wrap="square" lIns="0" rIns="0" tIns="0" bIns="0" anchor="t"/>
+          <a:lstStyle/>
+          <a:p>
+            <a:pPr algn="l">
+              <a:lnSpc>
+                <a:spcPct val="100000"/>
+              </a:lnSpc>
+              <a:spcBef>
+                <a:spcPts val="0"/>
+              </a:spcBef>
+              <a:spcAft>
+                <a:spcPts val="0"/>
+              </a:spcAft>
+            </a:pPr>
+            <a:r>
+              <a:rPr sz="1400" b="0">
+                <a:solidFill>
+                  <a:srgbClr val="5C564C"/>
+                </a:solidFill>
+                <a:latin typeface="Calibri"/>
+              </a:rPr>
+              <a:t>Monthly churn (weighted)</a:t>
+            </a:r>
+          </a:p>
+        </p:txBody>
+      </p:sp>
+      <p:sp>
+        <p:nvSpPr>
+          <p:cNvPr id="8" name="Rounded Rectangle 7"/>
+          <p:cNvSpPr/>
+          <p:nvPr/>
+        </p:nvSpPr>
+        <p:spPr>
+          <a:xfrm>
+            <a:off x="4307840" y="1463040"/>
+            <a:ext cx="3740912" cy="2057400"/>
+          </a:xfrm>
+          <a:prstGeom prst="roundRect">
+            <a:avLst>
+              <a:gd name="adj" fmla="val 8000"/>
+            </a:avLst>
+          </a:prstGeom>
+          <a:solidFill>
+            <a:srgbClr val="FBF9F5"/>
+          </a:solidFill>
+          <a:ln>
+            <a:noFill/>
+          </a:ln>
+        </p:spPr>
+        <p:style>
+          <a:lnRef idx="1">
+            <a:schemeClr val="accent1"/>
+          </a:lnRef>
+          <a:fillRef idx="3">
+            <a:schemeClr val="accent1"/>
+          </a:fillRef>
+          <a:effectRef idx="2">
+            <a:schemeClr val="accent1"/>
+          </a:effectRef>
+          <a:fontRef idx="minor">
+            <a:schemeClr val="lt1"/>
+          </a:fontRef>
+        </p:style>
+        <p:txBody>
+          <a:bodyPr rtlCol="0" anchor="ctr"/>
+          <a:lstStyle/>
+          <a:p>
+            <a:pPr algn="ctr"/>
+          </a:p>
+        </p:txBody>
+      </p:sp>
+      <p:sp>
+        <p:nvSpPr>
+          <p:cNvPr id="9" name="Rectangle 8"/>
+          <p:cNvSpPr/>
+          <p:nvPr/>
+        </p:nvSpPr>
+        <p:spPr>
+          <a:xfrm>
+            <a:off x="4307840" y="1463040"/>
+            <a:ext cx="3740912" cy="36576"/>
+          </a:xfrm>
+          <a:prstGeom prst="rect">
+            <a:avLst/>
+          </a:prstGeom>
+          <a:solidFill>
+            <a:srgbClr val="9C4221"/>
+          </a:solidFill>
+          <a:ln>
+            <a:noFill/>
+          </a:ln>
+        </p:spPr>
+        <p:style>
+          <a:lnRef idx="1">
+            <a:schemeClr val="accent1"/>
+          </a:lnRef>
+          <a:fillRef idx="3">
+            <a:schemeClr val="accent1"/>
+          </a:fillRef>
+          <a:effectRef idx="2">
+            <a:schemeClr val="accent1"/>
+          </a:effectRef>
+          <a:fontRef idx="minor">
+            <a:schemeClr val="lt1"/>
+          </a:fontRef>
+        </p:style>
+        <p:txBody>
+          <a:bodyPr rtlCol="0" anchor="ctr"/>
+          <a:lstStyle/>
+          <a:p>
+            <a:pPr algn="ctr"/>
+          </a:p>
+        </p:txBody>
+      </p:sp>
+      <p:sp>
+        <p:nvSpPr>
+          <p:cNvPr id="10" name="TextBox 9"/>
           <p:cNvSpPr txBox="1"/>
           <p:nvPr/>
         </p:nvSpPr>
         <p:spPr>
           <a:xfrm>
-            <a:off x="731520" y="4206240"/>
-            <a:ext cx="10728655" cy="1828800"/>
+            <a:off x="4445000" y="1691640"/>
+            <a:ext cx="3512312" cy="822960"/>
           </a:xfrm>
           <a:prstGeom prst="rect">
             <a:avLst/>
@@ -4450,14 +5338,505 @@
           <a:noFill/>
         </p:spPr>
         <p:txBody>
-          <a:bodyPr wrap="none">
-            <a:spAutoFit/>
-          </a:bodyPr>
-          <a:lstStyle/>
-          <a:p>
-            <a:r>
-              <a:rPr sz="2000"/>
+          <a:bodyPr wrap="square" lIns="0" rIns="0" tIns="0" bIns="0" anchor="ctr"/>
+          <a:lstStyle/>
+          <a:p>
+            <a:pPr algn="l">
+              <a:lnSpc>
+                <a:spcPct val="100000"/>
+              </a:lnSpc>
+              <a:spcBef>
+                <a:spcPts val="0"/>
+              </a:spcBef>
+              <a:spcAft>
+                <a:spcPts val="0"/>
+              </a:spcAft>
+            </a:pPr>
+            <a:r>
+              <a:rPr sz="4000" b="1">
+                <a:solidFill>
+                  <a:srgbClr val="1C1915"/>
+                </a:solidFill>
+                <a:latin typeface="Georgia"/>
+              </a:rPr>
+              <a:t>99.8%</a:t>
+            </a:r>
+          </a:p>
+        </p:txBody>
+      </p:sp>
+      <p:sp>
+        <p:nvSpPr>
+          <p:cNvPr id="11" name="TextBox 10"/>
+          <p:cNvSpPr txBox="1"/>
+          <p:nvPr/>
+        </p:nvSpPr>
+        <p:spPr>
+          <a:xfrm>
+            <a:off x="4445000" y="2560320"/>
+            <a:ext cx="3512312" cy="640080"/>
+          </a:xfrm>
+          <a:prstGeom prst="rect">
+            <a:avLst/>
+          </a:prstGeom>
+          <a:noFill/>
+        </p:spPr>
+        <p:txBody>
+          <a:bodyPr wrap="square" lIns="0" rIns="0" tIns="0" bIns="0" anchor="t"/>
+          <a:lstStyle/>
+          <a:p>
+            <a:pPr algn="l">
+              <a:lnSpc>
+                <a:spcPct val="100000"/>
+              </a:lnSpc>
+              <a:spcBef>
+                <a:spcPts val="0"/>
+              </a:spcBef>
+              <a:spcAft>
+                <a:spcPts val="0"/>
+              </a:spcAft>
+            </a:pPr>
+            <a:r>
+              <a:rPr sz="1400" b="0">
+                <a:solidFill>
+                  <a:srgbClr val="5C564C"/>
+                </a:solidFill>
+                <a:latin typeface="Calibri"/>
+              </a:rPr>
+              <a:t>Monthly NRR (weighted)</a:t>
+            </a:r>
+          </a:p>
+        </p:txBody>
+      </p:sp>
+      <p:sp>
+        <p:nvSpPr>
+          <p:cNvPr id="12" name="Rounded Rectangle 11"/>
+          <p:cNvSpPr/>
+          <p:nvPr/>
+        </p:nvSpPr>
+        <p:spPr>
+          <a:xfrm>
+            <a:off x="8048752" y="1463040"/>
+            <a:ext cx="3576320" cy="2057400"/>
+          </a:xfrm>
+          <a:prstGeom prst="roundRect">
+            <a:avLst>
+              <a:gd name="adj" fmla="val 8000"/>
+            </a:avLst>
+          </a:prstGeom>
+          <a:solidFill>
+            <a:srgbClr val="FBF9F5"/>
+          </a:solidFill>
+          <a:ln>
+            <a:noFill/>
+          </a:ln>
+        </p:spPr>
+        <p:style>
+          <a:lnRef idx="1">
+            <a:schemeClr val="accent1"/>
+          </a:lnRef>
+          <a:fillRef idx="3">
+            <a:schemeClr val="accent1"/>
+          </a:fillRef>
+          <a:effectRef idx="2">
+            <a:schemeClr val="accent1"/>
+          </a:effectRef>
+          <a:fontRef idx="minor">
+            <a:schemeClr val="lt1"/>
+          </a:fontRef>
+        </p:style>
+        <p:txBody>
+          <a:bodyPr rtlCol="0" anchor="ctr"/>
+          <a:lstStyle/>
+          <a:p>
+            <a:pPr algn="ctr"/>
+          </a:p>
+        </p:txBody>
+      </p:sp>
+      <p:sp>
+        <p:nvSpPr>
+          <p:cNvPr id="13" name="Rectangle 12"/>
+          <p:cNvSpPr/>
+          <p:nvPr/>
+        </p:nvSpPr>
+        <p:spPr>
+          <a:xfrm>
+            <a:off x="8048752" y="1463040"/>
+            <a:ext cx="3576320" cy="36576"/>
+          </a:xfrm>
+          <a:prstGeom prst="rect">
+            <a:avLst/>
+          </a:prstGeom>
+          <a:solidFill>
+            <a:srgbClr val="9C4221"/>
+          </a:solidFill>
+          <a:ln>
+            <a:noFill/>
+          </a:ln>
+        </p:spPr>
+        <p:style>
+          <a:lnRef idx="1">
+            <a:schemeClr val="accent1"/>
+          </a:lnRef>
+          <a:fillRef idx="3">
+            <a:schemeClr val="accent1"/>
+          </a:fillRef>
+          <a:effectRef idx="2">
+            <a:schemeClr val="accent1"/>
+          </a:effectRef>
+          <a:fontRef idx="minor">
+            <a:schemeClr val="lt1"/>
+          </a:fontRef>
+        </p:style>
+        <p:txBody>
+          <a:bodyPr rtlCol="0" anchor="ctr"/>
+          <a:lstStyle/>
+          <a:p>
+            <a:pPr algn="ctr"/>
+          </a:p>
+        </p:txBody>
+      </p:sp>
+      <p:sp>
+        <p:nvSpPr>
+          <p:cNvPr id="14" name="TextBox 13"/>
+          <p:cNvSpPr txBox="1"/>
+          <p:nvPr/>
+        </p:nvSpPr>
+        <p:spPr>
+          <a:xfrm>
+            <a:off x="8185912" y="1691640"/>
+            <a:ext cx="3347720" cy="822960"/>
+          </a:xfrm>
+          <a:prstGeom prst="rect">
+            <a:avLst/>
+          </a:prstGeom>
+          <a:noFill/>
+        </p:spPr>
+        <p:txBody>
+          <a:bodyPr wrap="square" lIns="0" rIns="0" tIns="0" bIns="0" anchor="ctr"/>
+          <a:lstStyle/>
+          <a:p>
+            <a:pPr algn="l">
+              <a:lnSpc>
+                <a:spcPct val="100000"/>
+              </a:lnSpc>
+              <a:spcBef>
+                <a:spcPts val="0"/>
+              </a:spcBef>
+              <a:spcAft>
+                <a:spcPts val="0"/>
+              </a:spcAft>
+            </a:pPr>
+            <a:r>
+              <a:rPr sz="4000" b="1">
+                <a:solidFill>
+                  <a:srgbClr val="1C1915"/>
+                </a:solidFill>
+                <a:latin typeface="Georgia"/>
+              </a:rPr>
+              <a:t>6,172</a:t>
+            </a:r>
+          </a:p>
+        </p:txBody>
+      </p:sp>
+      <p:sp>
+        <p:nvSpPr>
+          <p:cNvPr id="15" name="TextBox 14"/>
+          <p:cNvSpPr txBox="1"/>
+          <p:nvPr/>
+        </p:nvSpPr>
+        <p:spPr>
+          <a:xfrm>
+            <a:off x="8185912" y="2560320"/>
+            <a:ext cx="3347720" cy="640080"/>
+          </a:xfrm>
+          <a:prstGeom prst="rect">
+            <a:avLst/>
+          </a:prstGeom>
+          <a:noFill/>
+        </p:spPr>
+        <p:txBody>
+          <a:bodyPr wrap="square" lIns="0" rIns="0" tIns="0" bIns="0" anchor="t"/>
+          <a:lstStyle/>
+          <a:p>
+            <a:pPr algn="l">
+              <a:lnSpc>
+                <a:spcPct val="100000"/>
+              </a:lnSpc>
+              <a:spcBef>
+                <a:spcPts val="0"/>
+              </a:spcBef>
+              <a:spcAft>
+                <a:spcPts val="0"/>
+              </a:spcAft>
+            </a:pPr>
+            <a:r>
+              <a:rPr sz="1400" b="0">
+                <a:solidFill>
+                  <a:srgbClr val="5C564C"/>
+                </a:solidFill>
+                <a:latin typeface="Calibri"/>
+              </a:rPr>
+              <a:t>Active subscriptions</a:t>
+            </a:r>
+          </a:p>
+        </p:txBody>
+      </p:sp>
+      <p:sp>
+        <p:nvSpPr>
+          <p:cNvPr id="16" name="Rounded Rectangle 15"/>
+          <p:cNvSpPr/>
+          <p:nvPr/>
+        </p:nvSpPr>
+        <p:spPr>
+          <a:xfrm>
+            <a:off x="566928" y="3794760"/>
+            <a:ext cx="11058144" cy="1188720"/>
+          </a:xfrm>
+          <a:prstGeom prst="roundRect">
+            <a:avLst>
+              <a:gd name="adj" fmla="val 8000"/>
+            </a:avLst>
+          </a:prstGeom>
+          <a:solidFill>
+            <a:srgbClr val="FBF9F5"/>
+          </a:solidFill>
+          <a:ln>
+            <a:noFill/>
+          </a:ln>
+        </p:spPr>
+        <p:style>
+          <a:lnRef idx="1">
+            <a:schemeClr val="accent1"/>
+          </a:lnRef>
+          <a:fillRef idx="3">
+            <a:schemeClr val="accent1"/>
+          </a:fillRef>
+          <a:effectRef idx="2">
+            <a:schemeClr val="accent1"/>
+          </a:effectRef>
+          <a:fontRef idx="minor">
+            <a:schemeClr val="lt1"/>
+          </a:fontRef>
+        </p:style>
+        <p:txBody>
+          <a:bodyPr rtlCol="0" anchor="ctr"/>
+          <a:lstStyle/>
+          <a:p>
+            <a:pPr algn="ctr"/>
+          </a:p>
+        </p:txBody>
+      </p:sp>
+      <p:sp>
+        <p:nvSpPr>
+          <p:cNvPr id="17" name="Rectangle 16"/>
+          <p:cNvSpPr/>
+          <p:nvPr/>
+        </p:nvSpPr>
+        <p:spPr>
+          <a:xfrm>
+            <a:off x="566928" y="3794760"/>
+            <a:ext cx="54864" cy="1188720"/>
+          </a:xfrm>
+          <a:prstGeom prst="rect">
+            <a:avLst/>
+          </a:prstGeom>
+          <a:solidFill>
+            <a:srgbClr val="9C4221"/>
+          </a:solidFill>
+          <a:ln>
+            <a:noFill/>
+          </a:ln>
+        </p:spPr>
+        <p:style>
+          <a:lnRef idx="1">
+            <a:schemeClr val="accent1"/>
+          </a:lnRef>
+          <a:fillRef idx="3">
+            <a:schemeClr val="accent1"/>
+          </a:fillRef>
+          <a:effectRef idx="2">
+            <a:schemeClr val="accent1"/>
+          </a:effectRef>
+          <a:fontRef idx="minor">
+            <a:schemeClr val="lt1"/>
+          </a:fontRef>
+        </p:style>
+        <p:txBody>
+          <a:bodyPr rtlCol="0" anchor="ctr"/>
+          <a:lstStyle/>
+          <a:p>
+            <a:pPr algn="ctr"/>
+          </a:p>
+        </p:txBody>
+      </p:sp>
+      <p:sp>
+        <p:nvSpPr>
+          <p:cNvPr id="18" name="TextBox 17"/>
+          <p:cNvSpPr txBox="1"/>
+          <p:nvPr/>
+        </p:nvSpPr>
+        <p:spPr>
+          <a:xfrm>
+            <a:off x="841248" y="3886200"/>
+            <a:ext cx="10646664" cy="1005840"/>
+          </a:xfrm>
+          <a:prstGeom prst="rect">
+            <a:avLst/>
+          </a:prstGeom>
+          <a:noFill/>
+        </p:spPr>
+        <p:txBody>
+          <a:bodyPr wrap="square" lIns="0" rIns="0" tIns="0" bIns="0" anchor="ctr"/>
+          <a:lstStyle/>
+          <a:p>
+            <a:pPr algn="l">
+              <a:lnSpc>
+                <a:spcPct val="100000"/>
+              </a:lnSpc>
+              <a:spcBef>
+                <a:spcPts val="0"/>
+              </a:spcBef>
+              <a:spcAft>
+                <a:spcPts val="0"/>
+              </a:spcAft>
+            </a:pPr>
+            <a:r>
+              <a:rPr sz="1600" b="0">
+                <a:solidFill>
+                  <a:srgbClr val="1C1915"/>
+                </a:solidFill>
+                <a:latin typeface="Calibri"/>
+              </a:rPr>
               <a:t>Weighted monthly churn was 2.4% over the review period</a:t>
+            </a:r>
+          </a:p>
+        </p:txBody>
+      </p:sp>
+      <p:sp>
+        <p:nvSpPr>
+          <p:cNvPr id="19" name="Rectangle 18"/>
+          <p:cNvSpPr/>
+          <p:nvPr/>
+        </p:nvSpPr>
+        <p:spPr>
+          <a:xfrm>
+            <a:off x="566928" y="6437376"/>
+            <a:ext cx="11058144" cy="9144"/>
+          </a:xfrm>
+          <a:prstGeom prst="rect">
+            <a:avLst/>
+          </a:prstGeom>
+          <a:solidFill>
+            <a:srgbClr val="E3DCD0"/>
+          </a:solidFill>
+          <a:ln>
+            <a:noFill/>
+          </a:ln>
+        </p:spPr>
+        <p:style>
+          <a:lnRef idx="1">
+            <a:schemeClr val="accent1"/>
+          </a:lnRef>
+          <a:fillRef idx="3">
+            <a:schemeClr val="accent1"/>
+          </a:fillRef>
+          <a:effectRef idx="2">
+            <a:schemeClr val="accent1"/>
+          </a:effectRef>
+          <a:fontRef idx="minor">
+            <a:schemeClr val="lt1"/>
+          </a:fontRef>
+        </p:style>
+        <p:txBody>
+          <a:bodyPr rtlCol="0" anchor="ctr"/>
+          <a:lstStyle/>
+          <a:p>
+            <a:pPr algn="ctr"/>
+          </a:p>
+        </p:txBody>
+      </p:sp>
+      <p:sp>
+        <p:nvSpPr>
+          <p:cNvPr id="20" name="TextBox 19"/>
+          <p:cNvSpPr txBox="1"/>
+          <p:nvPr/>
+        </p:nvSpPr>
+        <p:spPr>
+          <a:xfrm>
+            <a:off x="566928" y="6501384"/>
+            <a:ext cx="10253472" cy="274320"/>
+          </a:xfrm>
+          <a:prstGeom prst="rect">
+            <a:avLst/>
+          </a:prstGeom>
+          <a:noFill/>
+        </p:spPr>
+        <p:txBody>
+          <a:bodyPr wrap="square" lIns="0" rIns="0" tIns="0" bIns="0" anchor="ctr"/>
+          <a:lstStyle/>
+          <a:p>
+            <a:pPr algn="l">
+              <a:lnSpc>
+                <a:spcPct val="100000"/>
+              </a:lnSpc>
+              <a:spcBef>
+                <a:spcPts val="0"/>
+              </a:spcBef>
+              <a:spcAft>
+                <a:spcPts val="0"/>
+              </a:spcAft>
+            </a:pPr>
+            <a:r>
+              <a:rPr sz="1200" b="0">
+                <a:solidFill>
+                  <a:srgbClr val="5C564C"/>
+                </a:solidFill>
+                <a:latin typeface="Calibri"/>
+              </a:rPr>
+              <a:t>Sources   Monthly churn (weighted)   ·   Monthly NRR (weighted)   ·   Active subscriptions</a:t>
+            </a:r>
+          </a:p>
+        </p:txBody>
+      </p:sp>
+      <p:sp>
+        <p:nvSpPr>
+          <p:cNvPr id="21" name="TextBox 20"/>
+          <p:cNvSpPr txBox="1"/>
+          <p:nvPr/>
+        </p:nvSpPr>
+        <p:spPr>
+          <a:xfrm>
+            <a:off x="10984992" y="6483096"/>
+            <a:ext cx="640080" cy="292608"/>
+          </a:xfrm>
+          <a:prstGeom prst="rect">
+            <a:avLst/>
+          </a:prstGeom>
+          <a:noFill/>
+        </p:spPr>
+        <p:txBody>
+          <a:bodyPr wrap="square" lIns="0" rIns="0" tIns="0" bIns="0" anchor="ctr"/>
+          <a:lstStyle/>
+          <a:p>
+            <a:pPr algn="r">
+              <a:lnSpc>
+                <a:spcPct val="100000"/>
+              </a:lnSpc>
+              <a:spcBef>
+                <a:spcPts val="0"/>
+              </a:spcBef>
+              <a:spcAft>
+                <a:spcPts val="0"/>
+              </a:spcAft>
+            </a:pPr>
+            <a:r>
+              <a:rPr sz="1300" b="0">
+                <a:solidFill>
+                  <a:srgbClr val="1C1915"/>
+                </a:solidFill>
+                <a:latin typeface="Georgia"/>
+              </a:rPr>
+              <a:t>II</a:t>
             </a:r>
           </a:p>
         </p:txBody>
@@ -4473,6 +5852,14 @@
 <file path=ppt/slides/slide3.xml><?xml version="1.0" encoding="utf-8"?>
 <p:sld xmlns:a="http://schemas.openxmlformats.org/drawingml/2006/main" xmlns:p="http://schemas.openxmlformats.org/presentationml/2006/main" xmlns:r="http://schemas.openxmlformats.org/officeDocument/2006/relationships">
   <p:cSld>
+    <p:bg>
+      <p:bgPr>
+        <a:solidFill>
+          <a:srgbClr val="F4F0E8"/>
+        </a:solidFill>
+        <a:effectLst/>
+      </p:bgPr>
+    </p:bg>
     <p:spTree>
       <p:nvGrpSpPr>
         <p:cNvPr id="1" name=""/>
@@ -4482,36 +5869,146 @@
       <p:grpSpPr/>
       <p:sp>
         <p:nvSpPr>
-          <p:cNvPr id="2" name="Title 1"/>
-          <p:cNvSpPr>
-            <a:spLocks noGrp="1"/>
-          </p:cNvSpPr>
-          <p:nvPr>
-            <p:ph type="title"/>
-          </p:nvPr>
-        </p:nvSpPr>
-        <p:spPr/>
-        <p:txBody>
-          <a:bodyPr/>
-          <a:lstStyle/>
-          <a:p>
-            <a:r>
-              <a:t>Monthly churn trend</a:t>
-            </a:r>
+          <p:cNvPr id="2" name="TextBox 1"/>
+          <p:cNvSpPr txBox="1"/>
+          <p:nvPr/>
+        </p:nvSpPr>
+        <p:spPr>
+          <a:xfrm>
+            <a:off x="566928" y="347472"/>
+            <a:ext cx="11058144" cy="841248"/>
+          </a:xfrm>
+          <a:prstGeom prst="rect">
+            <a:avLst/>
+          </a:prstGeom>
+          <a:noFill/>
+        </p:spPr>
+        <p:txBody>
+          <a:bodyPr wrap="square" lIns="0" rIns="0" tIns="0" bIns="0" anchor="b"/>
+          <a:lstStyle/>
+          <a:p>
+            <a:pPr algn="l">
+              <a:lnSpc>
+                <a:spcPct val="100000"/>
+              </a:lnSpc>
+              <a:spcBef>
+                <a:spcPts val="0"/>
+              </a:spcBef>
+              <a:spcAft>
+                <a:spcPts val="0"/>
+              </a:spcAft>
+            </a:pPr>
+            <a:r>
+              <a:rPr sz="2800" b="0">
+                <a:solidFill>
+                  <a:srgbClr val="1C1915"/>
+                </a:solidFill>
+                <a:latin typeface="Georgia"/>
+              </a:rPr>
+              <a:t>Monthly churn ended lower than it started</a:t>
+            </a:r>
+          </a:p>
+        </p:txBody>
+      </p:sp>
+      <p:sp>
+        <p:nvSpPr>
+          <p:cNvPr id="3" name="Rectangle 2"/>
+          <p:cNvSpPr/>
+          <p:nvPr/>
+        </p:nvSpPr>
+        <p:spPr>
+          <a:xfrm>
+            <a:off x="566928" y="1234440"/>
+            <a:ext cx="365760" cy="27432"/>
+          </a:xfrm>
+          <a:prstGeom prst="rect">
+            <a:avLst/>
+          </a:prstGeom>
+          <a:solidFill>
+            <a:srgbClr val="9C4221"/>
+          </a:solidFill>
+          <a:ln>
+            <a:noFill/>
+          </a:ln>
+        </p:spPr>
+        <p:style>
+          <a:lnRef idx="1">
+            <a:schemeClr val="accent1"/>
+          </a:lnRef>
+          <a:fillRef idx="3">
+            <a:schemeClr val="accent1"/>
+          </a:fillRef>
+          <a:effectRef idx="2">
+            <a:schemeClr val="accent1"/>
+          </a:effectRef>
+          <a:fontRef idx="minor">
+            <a:schemeClr val="lt1"/>
+          </a:fontRef>
+        </p:style>
+        <p:txBody>
+          <a:bodyPr rtlCol="0" anchor="ctr"/>
+          <a:lstStyle/>
+          <a:p>
+            <a:pPr algn="ctr"/>
+          </a:p>
+        </p:txBody>
+      </p:sp>
+      <p:sp>
+        <p:nvSpPr>
+          <p:cNvPr id="4" name="Rounded Rectangle 3"/>
+          <p:cNvSpPr/>
+          <p:nvPr/>
+        </p:nvSpPr>
+        <p:spPr>
+          <a:xfrm>
+            <a:off x="566928" y="1554480"/>
+            <a:ext cx="11058144" cy="4791456"/>
+          </a:xfrm>
+          <a:prstGeom prst="roundRect">
+            <a:avLst>
+              <a:gd name="adj" fmla="val 4000"/>
+            </a:avLst>
+          </a:prstGeom>
+          <a:solidFill>
+            <a:srgbClr val="FBF9F5"/>
+          </a:solidFill>
+          <a:ln>
+            <a:noFill/>
+          </a:ln>
+        </p:spPr>
+        <p:style>
+          <a:lnRef idx="1">
+            <a:schemeClr val="accent1"/>
+          </a:lnRef>
+          <a:fillRef idx="3">
+            <a:schemeClr val="accent1"/>
+          </a:fillRef>
+          <a:effectRef idx="2">
+            <a:schemeClr val="accent1"/>
+          </a:effectRef>
+          <a:fontRef idx="minor">
+            <a:schemeClr val="lt1"/>
+          </a:fontRef>
+        </p:style>
+        <p:txBody>
+          <a:bodyPr rtlCol="0" anchor="ctr"/>
+          <a:lstStyle/>
+          <a:p>
+            <a:pPr algn="ctr"/>
           </a:p>
         </p:txBody>
       </p:sp>
       <p:graphicFrame>
         <p:nvGraphicFramePr>
-          <p:cNvPr id="3" name="Chart 2"/>
+          <p:cNvPr id="5" name="Chart 4"/>
           <p:cNvGraphicFramePr>
             <a:graphicFrameLocks noGrp="1"/>
           </p:cNvGraphicFramePr>
           <p:nvPr/>
         </p:nvGraphicFramePr>
         <p:xfrm>
-          <a:off x="731520" y="1463040"/>
-          <a:ext cx="10728655" cy="4754880"/>
+          <a:off x="704088" y="1691640"/>
+          <a:ext cx="10783824" cy="4517136"/>
         </p:xfrm>
         <a:graphic>
           <a:graphicData uri="http://schemas.openxmlformats.org/drawingml/2006/chart">
@@ -4519,6 +6016,135 @@
           </a:graphicData>
         </a:graphic>
       </p:graphicFrame>
+      <p:sp>
+        <p:nvSpPr>
+          <p:cNvPr id="6" name="Rectangle 5"/>
+          <p:cNvSpPr/>
+          <p:nvPr/>
+        </p:nvSpPr>
+        <p:spPr>
+          <a:xfrm>
+            <a:off x="566928" y="6437376"/>
+            <a:ext cx="11058144" cy="9144"/>
+          </a:xfrm>
+          <a:prstGeom prst="rect">
+            <a:avLst/>
+          </a:prstGeom>
+          <a:solidFill>
+            <a:srgbClr val="E3DCD0"/>
+          </a:solidFill>
+          <a:ln>
+            <a:noFill/>
+          </a:ln>
+        </p:spPr>
+        <p:style>
+          <a:lnRef idx="1">
+            <a:schemeClr val="accent1"/>
+          </a:lnRef>
+          <a:fillRef idx="3">
+            <a:schemeClr val="accent1"/>
+          </a:fillRef>
+          <a:effectRef idx="2">
+            <a:schemeClr val="accent1"/>
+          </a:effectRef>
+          <a:fontRef idx="minor">
+            <a:schemeClr val="lt1"/>
+          </a:fontRef>
+        </p:style>
+        <p:txBody>
+          <a:bodyPr rtlCol="0" anchor="ctr"/>
+          <a:lstStyle/>
+          <a:p>
+            <a:pPr algn="ctr"/>
+          </a:p>
+        </p:txBody>
+      </p:sp>
+      <p:sp>
+        <p:nvSpPr>
+          <p:cNvPr id="7" name="TextBox 6"/>
+          <p:cNvSpPr txBox="1"/>
+          <p:nvPr/>
+        </p:nvSpPr>
+        <p:spPr>
+          <a:xfrm>
+            <a:off x="566928" y="6501384"/>
+            <a:ext cx="10253472" cy="274320"/>
+          </a:xfrm>
+          <a:prstGeom prst="rect">
+            <a:avLst/>
+          </a:prstGeom>
+          <a:noFill/>
+        </p:spPr>
+        <p:txBody>
+          <a:bodyPr wrap="square" lIns="0" rIns="0" tIns="0" bIns="0" anchor="ctr"/>
+          <a:lstStyle/>
+          <a:p>
+            <a:pPr algn="l">
+              <a:lnSpc>
+                <a:spcPct val="100000"/>
+              </a:lnSpc>
+              <a:spcBef>
+                <a:spcPts val="0"/>
+              </a:spcBef>
+              <a:spcAft>
+                <a:spcPts val="0"/>
+              </a:spcAft>
+            </a:pPr>
+            <a:r>
+              <a:rPr sz="1200" b="0">
+                <a:solidFill>
+                  <a:srgbClr val="5C564C"/>
+                </a:solidFill>
+                <a:latin typeface="Calibri"/>
+              </a:rPr>
+              <a:t>Sources   Monthly churn</a:t>
+            </a:r>
+          </a:p>
+        </p:txBody>
+      </p:sp>
+      <p:sp>
+        <p:nvSpPr>
+          <p:cNvPr id="8" name="TextBox 7"/>
+          <p:cNvSpPr txBox="1"/>
+          <p:nvPr/>
+        </p:nvSpPr>
+        <p:spPr>
+          <a:xfrm>
+            <a:off x="10984992" y="6483096"/>
+            <a:ext cx="640080" cy="292608"/>
+          </a:xfrm>
+          <a:prstGeom prst="rect">
+            <a:avLst/>
+          </a:prstGeom>
+          <a:noFill/>
+        </p:spPr>
+        <p:txBody>
+          <a:bodyPr wrap="square" lIns="0" rIns="0" tIns="0" bIns="0" anchor="ctr"/>
+          <a:lstStyle/>
+          <a:p>
+            <a:pPr algn="r">
+              <a:lnSpc>
+                <a:spcPct val="100000"/>
+              </a:lnSpc>
+              <a:spcBef>
+                <a:spcPts val="0"/>
+              </a:spcBef>
+              <a:spcAft>
+                <a:spcPts val="0"/>
+              </a:spcAft>
+            </a:pPr>
+            <a:r>
+              <a:rPr sz="1300" b="0">
+                <a:solidFill>
+                  <a:srgbClr val="1C1915"/>
+                </a:solidFill>
+                <a:latin typeface="Georgia"/>
+              </a:rPr>
+              <a:t>III</a:t>
+            </a:r>
+          </a:p>
+        </p:txBody>
+      </p:sp>
     </p:spTree>
   </p:cSld>
   <p:clrMapOvr>
@@ -4530,6 +6156,14 @@
 <file path=ppt/slides/slide4.xml><?xml version="1.0" encoding="utf-8"?>
 <p:sld xmlns:a="http://schemas.openxmlformats.org/drawingml/2006/main" xmlns:p="http://schemas.openxmlformats.org/presentationml/2006/main" xmlns:r="http://schemas.openxmlformats.org/officeDocument/2006/relationships">
   <p:cSld>
+    <p:bg>
+      <p:bgPr>
+        <a:solidFill>
+          <a:srgbClr val="F4F0E8"/>
+        </a:solidFill>
+        <a:effectLst/>
+      </p:bgPr>
+    </p:bg>
     <p:spTree>
       <p:nvGrpSpPr>
         <p:cNvPr id="1" name=""/>
@@ -4539,36 +6173,146 @@
       <p:grpSpPr/>
       <p:sp>
         <p:nvSpPr>
-          <p:cNvPr id="2" name="Title 1"/>
-          <p:cNvSpPr>
-            <a:spLocks noGrp="1"/>
-          </p:cNvSpPr>
-          <p:nvPr>
-            <p:ph type="title"/>
-          </p:nvPr>
-        </p:nvSpPr>
-        <p:spPr/>
-        <p:txBody>
-          <a:bodyPr/>
-          <a:lstStyle/>
-          <a:p>
-            <a:r>
-              <a:t>Monthly churn by segment</a:t>
-            </a:r>
+          <p:cNvPr id="2" name="TextBox 1"/>
+          <p:cNvSpPr txBox="1"/>
+          <p:nvPr/>
+        </p:nvSpPr>
+        <p:spPr>
+          <a:xfrm>
+            <a:off x="566928" y="347472"/>
+            <a:ext cx="11058144" cy="841248"/>
+          </a:xfrm>
+          <a:prstGeom prst="rect">
+            <a:avLst/>
+          </a:prstGeom>
+          <a:noFill/>
+        </p:spPr>
+        <p:txBody>
+          <a:bodyPr wrap="square" lIns="0" rIns="0" tIns="0" bIns="0" anchor="b"/>
+          <a:lstStyle/>
+          <a:p>
+            <a:pPr algn="l">
+              <a:lnSpc>
+                <a:spcPct val="100000"/>
+              </a:lnSpc>
+              <a:spcBef>
+                <a:spcPts val="0"/>
+              </a:spcBef>
+              <a:spcAft>
+                <a:spcPts val="0"/>
+              </a:spcAft>
+            </a:pPr>
+            <a:r>
+              <a:rPr sz="2800" b="0">
+                <a:solidFill>
+                  <a:srgbClr val="1C1915"/>
+                </a:solidFill>
+                <a:latin typeface="Georgia"/>
+              </a:rPr>
+              <a:t>Churn is highest in SMB</a:t>
+            </a:r>
+          </a:p>
+        </p:txBody>
+      </p:sp>
+      <p:sp>
+        <p:nvSpPr>
+          <p:cNvPr id="3" name="Rectangle 2"/>
+          <p:cNvSpPr/>
+          <p:nvPr/>
+        </p:nvSpPr>
+        <p:spPr>
+          <a:xfrm>
+            <a:off x="566928" y="1234440"/>
+            <a:ext cx="365760" cy="27432"/>
+          </a:xfrm>
+          <a:prstGeom prst="rect">
+            <a:avLst/>
+          </a:prstGeom>
+          <a:solidFill>
+            <a:srgbClr val="9C4221"/>
+          </a:solidFill>
+          <a:ln>
+            <a:noFill/>
+          </a:ln>
+        </p:spPr>
+        <p:style>
+          <a:lnRef idx="1">
+            <a:schemeClr val="accent1"/>
+          </a:lnRef>
+          <a:fillRef idx="3">
+            <a:schemeClr val="accent1"/>
+          </a:fillRef>
+          <a:effectRef idx="2">
+            <a:schemeClr val="accent1"/>
+          </a:effectRef>
+          <a:fontRef idx="minor">
+            <a:schemeClr val="lt1"/>
+          </a:fontRef>
+        </p:style>
+        <p:txBody>
+          <a:bodyPr rtlCol="0" anchor="ctr"/>
+          <a:lstStyle/>
+          <a:p>
+            <a:pPr algn="ctr"/>
+          </a:p>
+        </p:txBody>
+      </p:sp>
+      <p:sp>
+        <p:nvSpPr>
+          <p:cNvPr id="4" name="Rounded Rectangle 3"/>
+          <p:cNvSpPr/>
+          <p:nvPr/>
+        </p:nvSpPr>
+        <p:spPr>
+          <a:xfrm>
+            <a:off x="566928" y="1554480"/>
+            <a:ext cx="11058144" cy="4791456"/>
+          </a:xfrm>
+          <a:prstGeom prst="roundRect">
+            <a:avLst>
+              <a:gd name="adj" fmla="val 4000"/>
+            </a:avLst>
+          </a:prstGeom>
+          <a:solidFill>
+            <a:srgbClr val="FBF9F5"/>
+          </a:solidFill>
+          <a:ln>
+            <a:noFill/>
+          </a:ln>
+        </p:spPr>
+        <p:style>
+          <a:lnRef idx="1">
+            <a:schemeClr val="accent1"/>
+          </a:lnRef>
+          <a:fillRef idx="3">
+            <a:schemeClr val="accent1"/>
+          </a:fillRef>
+          <a:effectRef idx="2">
+            <a:schemeClr val="accent1"/>
+          </a:effectRef>
+          <a:fontRef idx="minor">
+            <a:schemeClr val="lt1"/>
+          </a:fontRef>
+        </p:style>
+        <p:txBody>
+          <a:bodyPr rtlCol="0" anchor="ctr"/>
+          <a:lstStyle/>
+          <a:p>
+            <a:pPr algn="ctr"/>
           </a:p>
         </p:txBody>
       </p:sp>
       <p:graphicFrame>
         <p:nvGraphicFramePr>
-          <p:cNvPr id="3" name="Chart 2"/>
+          <p:cNvPr id="5" name="Chart 4"/>
           <p:cNvGraphicFramePr>
             <a:graphicFrameLocks noGrp="1"/>
           </p:cNvGraphicFramePr>
           <p:nvPr/>
         </p:nvGraphicFramePr>
         <p:xfrm>
-          <a:off x="731520" y="1463040"/>
-          <a:ext cx="10728655" cy="4754880"/>
+          <a:off x="704088" y="1691640"/>
+          <a:ext cx="10783824" cy="4517136"/>
         </p:xfrm>
         <a:graphic>
           <a:graphicData uri="http://schemas.openxmlformats.org/drawingml/2006/chart">
@@ -4576,6 +6320,135 @@
           </a:graphicData>
         </a:graphic>
       </p:graphicFrame>
+      <p:sp>
+        <p:nvSpPr>
+          <p:cNvPr id="6" name="Rectangle 5"/>
+          <p:cNvSpPr/>
+          <p:nvPr/>
+        </p:nvSpPr>
+        <p:spPr>
+          <a:xfrm>
+            <a:off x="566928" y="6437376"/>
+            <a:ext cx="11058144" cy="9144"/>
+          </a:xfrm>
+          <a:prstGeom prst="rect">
+            <a:avLst/>
+          </a:prstGeom>
+          <a:solidFill>
+            <a:srgbClr val="E3DCD0"/>
+          </a:solidFill>
+          <a:ln>
+            <a:noFill/>
+          </a:ln>
+        </p:spPr>
+        <p:style>
+          <a:lnRef idx="1">
+            <a:schemeClr val="accent1"/>
+          </a:lnRef>
+          <a:fillRef idx="3">
+            <a:schemeClr val="accent1"/>
+          </a:fillRef>
+          <a:effectRef idx="2">
+            <a:schemeClr val="accent1"/>
+          </a:effectRef>
+          <a:fontRef idx="minor">
+            <a:schemeClr val="lt1"/>
+          </a:fontRef>
+        </p:style>
+        <p:txBody>
+          <a:bodyPr rtlCol="0" anchor="ctr"/>
+          <a:lstStyle/>
+          <a:p>
+            <a:pPr algn="ctr"/>
+          </a:p>
+        </p:txBody>
+      </p:sp>
+      <p:sp>
+        <p:nvSpPr>
+          <p:cNvPr id="7" name="TextBox 6"/>
+          <p:cNvSpPr txBox="1"/>
+          <p:nvPr/>
+        </p:nvSpPr>
+        <p:spPr>
+          <a:xfrm>
+            <a:off x="566928" y="6501384"/>
+            <a:ext cx="10253472" cy="274320"/>
+          </a:xfrm>
+          <a:prstGeom prst="rect">
+            <a:avLst/>
+          </a:prstGeom>
+          <a:noFill/>
+        </p:spPr>
+        <p:txBody>
+          <a:bodyPr wrap="square" lIns="0" rIns="0" tIns="0" bIns="0" anchor="ctr"/>
+          <a:lstStyle/>
+          <a:p>
+            <a:pPr algn="l">
+              <a:lnSpc>
+                <a:spcPct val="100000"/>
+              </a:lnSpc>
+              <a:spcBef>
+                <a:spcPts val="0"/>
+              </a:spcBef>
+              <a:spcAft>
+                <a:spcPts val="0"/>
+              </a:spcAft>
+            </a:pPr>
+            <a:r>
+              <a:rPr sz="1200" b="0">
+                <a:solidFill>
+                  <a:srgbClr val="5C564C"/>
+                </a:solidFill>
+                <a:latin typeface="Calibri"/>
+              </a:rPr>
+              <a:t>Sources   Weighted monthly churn by segment</a:t>
+            </a:r>
+          </a:p>
+        </p:txBody>
+      </p:sp>
+      <p:sp>
+        <p:nvSpPr>
+          <p:cNvPr id="8" name="TextBox 7"/>
+          <p:cNvSpPr txBox="1"/>
+          <p:nvPr/>
+        </p:nvSpPr>
+        <p:spPr>
+          <a:xfrm>
+            <a:off x="10984992" y="6483096"/>
+            <a:ext cx="640080" cy="292608"/>
+          </a:xfrm>
+          <a:prstGeom prst="rect">
+            <a:avLst/>
+          </a:prstGeom>
+          <a:noFill/>
+        </p:spPr>
+        <p:txBody>
+          <a:bodyPr wrap="square" lIns="0" rIns="0" tIns="0" bIns="0" anchor="ctr"/>
+          <a:lstStyle/>
+          <a:p>
+            <a:pPr algn="r">
+              <a:lnSpc>
+                <a:spcPct val="100000"/>
+              </a:lnSpc>
+              <a:spcBef>
+                <a:spcPts val="0"/>
+              </a:spcBef>
+              <a:spcAft>
+                <a:spcPts val="0"/>
+              </a:spcAft>
+            </a:pPr>
+            <a:r>
+              <a:rPr sz="1300" b="0">
+                <a:solidFill>
+                  <a:srgbClr val="1C1915"/>
+                </a:solidFill>
+                <a:latin typeface="Georgia"/>
+              </a:rPr>
+              <a:t>IV</a:t>
+            </a:r>
+          </a:p>
+        </p:txBody>
+      </p:sp>
     </p:spTree>
   </p:cSld>
   <p:clrMapOvr>
@@ -4587,6 +6460,14 @@
 <file path=ppt/slides/slide5.xml><?xml version="1.0" encoding="utf-8"?>
 <p:sld xmlns:a="http://schemas.openxmlformats.org/drawingml/2006/main" xmlns:p="http://schemas.openxmlformats.org/presentationml/2006/main" xmlns:r="http://schemas.openxmlformats.org/officeDocument/2006/relationships">
   <p:cSld>
+    <p:bg>
+      <p:bgPr>
+        <a:solidFill>
+          <a:srgbClr val="F4F0E8"/>
+        </a:solidFill>
+        <a:effectLst/>
+      </p:bgPr>
+    </p:bg>
     <p:spTree>
       <p:nvGrpSpPr>
         <p:cNvPr id="1" name=""/>
@@ -4596,20 +6477,42 @@
       <p:grpSpPr/>
       <p:sp>
         <p:nvSpPr>
-          <p:cNvPr id="2" name="Title 1"/>
-          <p:cNvSpPr>
-            <a:spLocks noGrp="1"/>
-          </p:cNvSpPr>
-          <p:nvPr>
-            <p:ph type="title"/>
-          </p:nvPr>
-        </p:nvSpPr>
-        <p:spPr/>
-        <p:txBody>
-          <a:bodyPr/>
-          <a:lstStyle/>
-          <a:p>
-            <a:r>
+          <p:cNvPr id="2" name="TextBox 1"/>
+          <p:cNvSpPr txBox="1"/>
+          <p:nvPr/>
+        </p:nvSpPr>
+        <p:spPr>
+          <a:xfrm>
+            <a:off x="566928" y="347472"/>
+            <a:ext cx="11058144" cy="841248"/>
+          </a:xfrm>
+          <a:prstGeom prst="rect">
+            <a:avLst/>
+          </a:prstGeom>
+          <a:noFill/>
+        </p:spPr>
+        <p:txBody>
+          <a:bodyPr wrap="square" lIns="0" rIns="0" tIns="0" bIns="0" anchor="b"/>
+          <a:lstStyle/>
+          <a:p>
+            <a:pPr algn="l">
+              <a:lnSpc>
+                <a:spcPct val="100000"/>
+              </a:lnSpc>
+              <a:spcBef>
+                <a:spcPts val="0"/>
+              </a:spcBef>
+              <a:spcAft>
+                <a:spcPts val="0"/>
+              </a:spcAft>
+            </a:pPr>
+            <a:r>
+              <a:rPr sz="2800" b="0">
+                <a:solidFill>
+                  <a:srgbClr val="1C1915"/>
+                </a:solidFill>
+                <a:latin typeface="Georgia"/>
+              </a:rPr>
               <a:t>Sources</a:t>
             </a:r>
           </a:p>
@@ -4617,46 +6520,989 @@
       </p:sp>
       <p:sp>
         <p:nvSpPr>
-          <p:cNvPr id="3" name="Content Placeholder 2"/>
-          <p:cNvSpPr>
-            <a:spLocks noGrp="1"/>
-          </p:cNvSpPr>
-          <p:nvPr>
-            <p:ph idx="1"/>
-          </p:nvPr>
-        </p:nvSpPr>
-        <p:spPr/>
-        <p:txBody>
-          <a:bodyPr/>
-          <a:lstStyle/>
-          <a:p>
-            <a:r>
-              <a:rPr sz="1400"/>
-              <a:t>f1 · Monthly churn (weighted) · churn_rate_quarter · main.cs.churn_monthly · statement duckdb-eed72c8e07d1 · queried 2026-10-18 04:18 UTC</a:t>
-            </a:r>
-          </a:p>
-          <a:p>
-            <a:r>
-              <a:rPr sz="1400"/>
-              <a:t>f2 · Monthly NRR (weighted) · nrr_quarter · main.cs.revenue_monthly · statement duckdb-5075d99a6ed2 · queried 2026-10-18 04:18 UTC</a:t>
-            </a:r>
-          </a:p>
-          <a:p>
-            <a:r>
-              <a:rPr sz="1400"/>
-              <a:t>f3 · Active subscriptions · active_subscriptions · main.cs.churn_monthly · statement duckdb-f73e339fbd2f · queried 2026-10-18 04:18 UTC</a:t>
-            </a:r>
-          </a:p>
-          <a:p>
-            <a:r>
-              <a:rPr sz="1400"/>
-              <a:t>f4 · Monthly churn · churn_trend_monthly · main.cs.churn_monthly · statement duckdb-652fcac2b08a · queried 2026-10-18 04:18 UTC</a:t>
-            </a:r>
-          </a:p>
-          <a:p>
-            <a:r>
-              <a:rPr sz="1400"/>
-              <a:t>f5 · Weighted monthly churn by segment · churn_by_segment · main.cs.churn_monthly · statement duckdb-f610159e247c · queried 2026-10-18 04:18 UTC</a:t>
+          <p:cNvPr id="3" name="Rectangle 2"/>
+          <p:cNvSpPr/>
+          <p:nvPr/>
+        </p:nvSpPr>
+        <p:spPr>
+          <a:xfrm>
+            <a:off x="566928" y="1234440"/>
+            <a:ext cx="365760" cy="27432"/>
+          </a:xfrm>
+          <a:prstGeom prst="rect">
+            <a:avLst/>
+          </a:prstGeom>
+          <a:solidFill>
+            <a:srgbClr val="9C4221"/>
+          </a:solidFill>
+          <a:ln>
+            <a:noFill/>
+          </a:ln>
+        </p:spPr>
+        <p:style>
+          <a:lnRef idx="1">
+            <a:schemeClr val="accent1"/>
+          </a:lnRef>
+          <a:fillRef idx="3">
+            <a:schemeClr val="accent1"/>
+          </a:fillRef>
+          <a:effectRef idx="2">
+            <a:schemeClr val="accent1"/>
+          </a:effectRef>
+          <a:fontRef idx="minor">
+            <a:schemeClr val="lt1"/>
+          </a:fontRef>
+        </p:style>
+        <p:txBody>
+          <a:bodyPr rtlCol="0" anchor="ctr"/>
+          <a:lstStyle/>
+          <a:p>
+            <a:pPr algn="ctr"/>
+          </a:p>
+        </p:txBody>
+      </p:sp>
+      <p:sp>
+        <p:nvSpPr>
+          <p:cNvPr id="4" name="Rectangle 3"/>
+          <p:cNvSpPr/>
+          <p:nvPr/>
+        </p:nvSpPr>
+        <p:spPr>
+          <a:xfrm>
+            <a:off x="566928" y="2322576"/>
+            <a:ext cx="11058144" cy="9144"/>
+          </a:xfrm>
+          <a:prstGeom prst="rect">
+            <a:avLst/>
+          </a:prstGeom>
+          <a:solidFill>
+            <a:srgbClr val="E3DCD0"/>
+          </a:solidFill>
+          <a:ln>
+            <a:noFill/>
+          </a:ln>
+        </p:spPr>
+        <p:style>
+          <a:lnRef idx="1">
+            <a:schemeClr val="accent1"/>
+          </a:lnRef>
+          <a:fillRef idx="3">
+            <a:schemeClr val="accent1"/>
+          </a:fillRef>
+          <a:effectRef idx="2">
+            <a:schemeClr val="accent1"/>
+          </a:effectRef>
+          <a:fontRef idx="minor">
+            <a:schemeClr val="lt1"/>
+          </a:fontRef>
+        </p:style>
+        <p:txBody>
+          <a:bodyPr rtlCol="0" anchor="ctr"/>
+          <a:lstStyle/>
+          <a:p>
+            <a:pPr algn="ctr"/>
+          </a:p>
+        </p:txBody>
+      </p:sp>
+      <p:sp>
+        <p:nvSpPr>
+          <p:cNvPr id="5" name="TextBox 4"/>
+          <p:cNvSpPr txBox="1"/>
+          <p:nvPr/>
+        </p:nvSpPr>
+        <p:spPr>
+          <a:xfrm>
+            <a:off x="566928" y="1600200"/>
+            <a:ext cx="914400" cy="704088"/>
+          </a:xfrm>
+          <a:prstGeom prst="rect">
+            <a:avLst/>
+          </a:prstGeom>
+          <a:noFill/>
+        </p:spPr>
+        <p:txBody>
+          <a:bodyPr wrap="square" lIns="0" rIns="0" tIns="0" bIns="0" anchor="ctr"/>
+          <a:lstStyle/>
+          <a:p>
+            <a:pPr algn="l">
+              <a:lnSpc>
+                <a:spcPct val="100000"/>
+              </a:lnSpc>
+              <a:spcBef>
+                <a:spcPts val="0"/>
+              </a:spcBef>
+              <a:spcAft>
+                <a:spcPts val="0"/>
+              </a:spcAft>
+            </a:pPr>
+            <a:r>
+              <a:rPr sz="1500" b="0">
+                <a:solidFill>
+                  <a:srgbClr val="9C4221"/>
+                </a:solidFill>
+                <a:latin typeface="Georgia"/>
+              </a:rPr>
+              <a:t>f1 ·</a:t>
+            </a:r>
+          </a:p>
+        </p:txBody>
+      </p:sp>
+      <p:sp>
+        <p:nvSpPr>
+          <p:cNvPr id="6" name="TextBox 5"/>
+          <p:cNvSpPr txBox="1"/>
+          <p:nvPr/>
+        </p:nvSpPr>
+        <p:spPr>
+          <a:xfrm>
+            <a:off x="1572768" y="1600200"/>
+            <a:ext cx="3980931" cy="704088"/>
+          </a:xfrm>
+          <a:prstGeom prst="rect">
+            <a:avLst/>
+          </a:prstGeom>
+          <a:noFill/>
+        </p:spPr>
+        <p:txBody>
+          <a:bodyPr wrap="square" lIns="0" rIns="0" tIns="0" bIns="0" anchor="ctr"/>
+          <a:lstStyle/>
+          <a:p>
+            <a:pPr algn="l">
+              <a:lnSpc>
+                <a:spcPct val="100000"/>
+              </a:lnSpc>
+              <a:spcBef>
+                <a:spcPts val="0"/>
+              </a:spcBef>
+              <a:spcAft>
+                <a:spcPts val="0"/>
+              </a:spcAft>
+            </a:pPr>
+            <a:r>
+              <a:rPr sz="1500" b="0">
+                <a:solidFill>
+                  <a:srgbClr val="1C1915"/>
+                </a:solidFill>
+                <a:latin typeface="Calibri"/>
+              </a:rPr>
+              <a:t>Monthly churn (weighted)</a:t>
+            </a:r>
+          </a:p>
+        </p:txBody>
+      </p:sp>
+      <p:sp>
+        <p:nvSpPr>
+          <p:cNvPr id="7" name="TextBox 6"/>
+          <p:cNvSpPr txBox="1"/>
+          <p:nvPr/>
+        </p:nvSpPr>
+        <p:spPr>
+          <a:xfrm>
+            <a:off x="5553699" y="1600200"/>
+            <a:ext cx="6071373" cy="704088"/>
+          </a:xfrm>
+          <a:prstGeom prst="rect">
+            <a:avLst/>
+          </a:prstGeom>
+          <a:noFill/>
+        </p:spPr>
+        <p:txBody>
+          <a:bodyPr wrap="square" lIns="0" rIns="0" tIns="0" bIns="0" anchor="ctr"/>
+          <a:lstStyle/>
+          <a:p>
+            <a:pPr algn="l">
+              <a:lnSpc>
+                <a:spcPct val="100000"/>
+              </a:lnSpc>
+              <a:spcBef>
+                <a:spcPts val="0"/>
+              </a:spcBef>
+              <a:spcAft>
+                <a:spcPts val="0"/>
+              </a:spcAft>
+            </a:pPr>
+            <a:r>
+              <a:rPr sz="1300" b="0">
+                <a:solidFill>
+                  <a:srgbClr val="5C564C"/>
+                </a:solidFill>
+                <a:latin typeface="Calibri"/>
+              </a:rPr>
+              <a:t>churn_rate_quarter    main.cs.churn_monthly</a:t>
+            </a:r>
+          </a:p>
+        </p:txBody>
+      </p:sp>
+      <p:sp>
+        <p:nvSpPr>
+          <p:cNvPr id="8" name="Rectangle 7"/>
+          <p:cNvSpPr/>
+          <p:nvPr/>
+        </p:nvSpPr>
+        <p:spPr>
+          <a:xfrm>
+            <a:off x="566928" y="3054096"/>
+            <a:ext cx="11058144" cy="9144"/>
+          </a:xfrm>
+          <a:prstGeom prst="rect">
+            <a:avLst/>
+          </a:prstGeom>
+          <a:solidFill>
+            <a:srgbClr val="E3DCD0"/>
+          </a:solidFill>
+          <a:ln>
+            <a:noFill/>
+          </a:ln>
+        </p:spPr>
+        <p:style>
+          <a:lnRef idx="1">
+            <a:schemeClr val="accent1"/>
+          </a:lnRef>
+          <a:fillRef idx="3">
+            <a:schemeClr val="accent1"/>
+          </a:fillRef>
+          <a:effectRef idx="2">
+            <a:schemeClr val="accent1"/>
+          </a:effectRef>
+          <a:fontRef idx="minor">
+            <a:schemeClr val="lt1"/>
+          </a:fontRef>
+        </p:style>
+        <p:txBody>
+          <a:bodyPr rtlCol="0" anchor="ctr"/>
+          <a:lstStyle/>
+          <a:p>
+            <a:pPr algn="ctr"/>
+          </a:p>
+        </p:txBody>
+      </p:sp>
+      <p:sp>
+        <p:nvSpPr>
+          <p:cNvPr id="9" name="TextBox 8"/>
+          <p:cNvSpPr txBox="1"/>
+          <p:nvPr/>
+        </p:nvSpPr>
+        <p:spPr>
+          <a:xfrm>
+            <a:off x="566928" y="2331720"/>
+            <a:ext cx="914400" cy="704088"/>
+          </a:xfrm>
+          <a:prstGeom prst="rect">
+            <a:avLst/>
+          </a:prstGeom>
+          <a:noFill/>
+        </p:spPr>
+        <p:txBody>
+          <a:bodyPr wrap="square" lIns="0" rIns="0" tIns="0" bIns="0" anchor="ctr"/>
+          <a:lstStyle/>
+          <a:p>
+            <a:pPr algn="l">
+              <a:lnSpc>
+                <a:spcPct val="100000"/>
+              </a:lnSpc>
+              <a:spcBef>
+                <a:spcPts val="0"/>
+              </a:spcBef>
+              <a:spcAft>
+                <a:spcPts val="0"/>
+              </a:spcAft>
+            </a:pPr>
+            <a:r>
+              <a:rPr sz="1500" b="0">
+                <a:solidFill>
+                  <a:srgbClr val="9C4221"/>
+                </a:solidFill>
+                <a:latin typeface="Georgia"/>
+              </a:rPr>
+              <a:t>f2 ·</a:t>
+            </a:r>
+          </a:p>
+        </p:txBody>
+      </p:sp>
+      <p:sp>
+        <p:nvSpPr>
+          <p:cNvPr id="10" name="TextBox 9"/>
+          <p:cNvSpPr txBox="1"/>
+          <p:nvPr/>
+        </p:nvSpPr>
+        <p:spPr>
+          <a:xfrm>
+            <a:off x="1572768" y="2331720"/>
+            <a:ext cx="3980931" cy="704088"/>
+          </a:xfrm>
+          <a:prstGeom prst="rect">
+            <a:avLst/>
+          </a:prstGeom>
+          <a:noFill/>
+        </p:spPr>
+        <p:txBody>
+          <a:bodyPr wrap="square" lIns="0" rIns="0" tIns="0" bIns="0" anchor="ctr"/>
+          <a:lstStyle/>
+          <a:p>
+            <a:pPr algn="l">
+              <a:lnSpc>
+                <a:spcPct val="100000"/>
+              </a:lnSpc>
+              <a:spcBef>
+                <a:spcPts val="0"/>
+              </a:spcBef>
+              <a:spcAft>
+                <a:spcPts val="0"/>
+              </a:spcAft>
+            </a:pPr>
+            <a:r>
+              <a:rPr sz="1500" b="0">
+                <a:solidFill>
+                  <a:srgbClr val="1C1915"/>
+                </a:solidFill>
+                <a:latin typeface="Calibri"/>
+              </a:rPr>
+              <a:t>Monthly NRR (weighted)</a:t>
+            </a:r>
+          </a:p>
+        </p:txBody>
+      </p:sp>
+      <p:sp>
+        <p:nvSpPr>
+          <p:cNvPr id="11" name="TextBox 10"/>
+          <p:cNvSpPr txBox="1"/>
+          <p:nvPr/>
+        </p:nvSpPr>
+        <p:spPr>
+          <a:xfrm>
+            <a:off x="5553699" y="2331720"/>
+            <a:ext cx="6071373" cy="704088"/>
+          </a:xfrm>
+          <a:prstGeom prst="rect">
+            <a:avLst/>
+          </a:prstGeom>
+          <a:noFill/>
+        </p:spPr>
+        <p:txBody>
+          <a:bodyPr wrap="square" lIns="0" rIns="0" tIns="0" bIns="0" anchor="ctr"/>
+          <a:lstStyle/>
+          <a:p>
+            <a:pPr algn="l">
+              <a:lnSpc>
+                <a:spcPct val="100000"/>
+              </a:lnSpc>
+              <a:spcBef>
+                <a:spcPts val="0"/>
+              </a:spcBef>
+              <a:spcAft>
+                <a:spcPts val="0"/>
+              </a:spcAft>
+            </a:pPr>
+            <a:r>
+              <a:rPr sz="1300" b="0">
+                <a:solidFill>
+                  <a:srgbClr val="5C564C"/>
+                </a:solidFill>
+                <a:latin typeface="Calibri"/>
+              </a:rPr>
+              <a:t>nrr_quarter    main.cs.revenue_monthly</a:t>
+            </a:r>
+          </a:p>
+        </p:txBody>
+      </p:sp>
+      <p:sp>
+        <p:nvSpPr>
+          <p:cNvPr id="12" name="Rectangle 11"/>
+          <p:cNvSpPr/>
+          <p:nvPr/>
+        </p:nvSpPr>
+        <p:spPr>
+          <a:xfrm>
+            <a:off x="566928" y="3785616"/>
+            <a:ext cx="11058144" cy="9144"/>
+          </a:xfrm>
+          <a:prstGeom prst="rect">
+            <a:avLst/>
+          </a:prstGeom>
+          <a:solidFill>
+            <a:srgbClr val="E3DCD0"/>
+          </a:solidFill>
+          <a:ln>
+            <a:noFill/>
+          </a:ln>
+        </p:spPr>
+        <p:style>
+          <a:lnRef idx="1">
+            <a:schemeClr val="accent1"/>
+          </a:lnRef>
+          <a:fillRef idx="3">
+            <a:schemeClr val="accent1"/>
+          </a:fillRef>
+          <a:effectRef idx="2">
+            <a:schemeClr val="accent1"/>
+          </a:effectRef>
+          <a:fontRef idx="minor">
+            <a:schemeClr val="lt1"/>
+          </a:fontRef>
+        </p:style>
+        <p:txBody>
+          <a:bodyPr rtlCol="0" anchor="ctr"/>
+          <a:lstStyle/>
+          <a:p>
+            <a:pPr algn="ctr"/>
+          </a:p>
+        </p:txBody>
+      </p:sp>
+      <p:sp>
+        <p:nvSpPr>
+          <p:cNvPr id="13" name="TextBox 12"/>
+          <p:cNvSpPr txBox="1"/>
+          <p:nvPr/>
+        </p:nvSpPr>
+        <p:spPr>
+          <a:xfrm>
+            <a:off x="566928" y="3063240"/>
+            <a:ext cx="914400" cy="704088"/>
+          </a:xfrm>
+          <a:prstGeom prst="rect">
+            <a:avLst/>
+          </a:prstGeom>
+          <a:noFill/>
+        </p:spPr>
+        <p:txBody>
+          <a:bodyPr wrap="square" lIns="0" rIns="0" tIns="0" bIns="0" anchor="ctr"/>
+          <a:lstStyle/>
+          <a:p>
+            <a:pPr algn="l">
+              <a:lnSpc>
+                <a:spcPct val="100000"/>
+              </a:lnSpc>
+              <a:spcBef>
+                <a:spcPts val="0"/>
+              </a:spcBef>
+              <a:spcAft>
+                <a:spcPts val="0"/>
+              </a:spcAft>
+            </a:pPr>
+            <a:r>
+              <a:rPr sz="1500" b="0">
+                <a:solidFill>
+                  <a:srgbClr val="9C4221"/>
+                </a:solidFill>
+                <a:latin typeface="Georgia"/>
+              </a:rPr>
+              <a:t>f3 ·</a:t>
+            </a:r>
+          </a:p>
+        </p:txBody>
+      </p:sp>
+      <p:sp>
+        <p:nvSpPr>
+          <p:cNvPr id="14" name="TextBox 13"/>
+          <p:cNvSpPr txBox="1"/>
+          <p:nvPr/>
+        </p:nvSpPr>
+        <p:spPr>
+          <a:xfrm>
+            <a:off x="1572768" y="3063240"/>
+            <a:ext cx="3980931" cy="704088"/>
+          </a:xfrm>
+          <a:prstGeom prst="rect">
+            <a:avLst/>
+          </a:prstGeom>
+          <a:noFill/>
+        </p:spPr>
+        <p:txBody>
+          <a:bodyPr wrap="square" lIns="0" rIns="0" tIns="0" bIns="0" anchor="ctr"/>
+          <a:lstStyle/>
+          <a:p>
+            <a:pPr algn="l">
+              <a:lnSpc>
+                <a:spcPct val="100000"/>
+              </a:lnSpc>
+              <a:spcBef>
+                <a:spcPts val="0"/>
+              </a:spcBef>
+              <a:spcAft>
+                <a:spcPts val="0"/>
+              </a:spcAft>
+            </a:pPr>
+            <a:r>
+              <a:rPr sz="1500" b="0">
+                <a:solidFill>
+                  <a:srgbClr val="1C1915"/>
+                </a:solidFill>
+                <a:latin typeface="Calibri"/>
+              </a:rPr>
+              <a:t>Active subscriptions</a:t>
+            </a:r>
+          </a:p>
+        </p:txBody>
+      </p:sp>
+      <p:sp>
+        <p:nvSpPr>
+          <p:cNvPr id="15" name="TextBox 14"/>
+          <p:cNvSpPr txBox="1"/>
+          <p:nvPr/>
+        </p:nvSpPr>
+        <p:spPr>
+          <a:xfrm>
+            <a:off x="5553699" y="3063240"/>
+            <a:ext cx="6071373" cy="704088"/>
+          </a:xfrm>
+          <a:prstGeom prst="rect">
+            <a:avLst/>
+          </a:prstGeom>
+          <a:noFill/>
+        </p:spPr>
+        <p:txBody>
+          <a:bodyPr wrap="square" lIns="0" rIns="0" tIns="0" bIns="0" anchor="ctr"/>
+          <a:lstStyle/>
+          <a:p>
+            <a:pPr algn="l">
+              <a:lnSpc>
+                <a:spcPct val="100000"/>
+              </a:lnSpc>
+              <a:spcBef>
+                <a:spcPts val="0"/>
+              </a:spcBef>
+              <a:spcAft>
+                <a:spcPts val="0"/>
+              </a:spcAft>
+            </a:pPr>
+            <a:r>
+              <a:rPr sz="1300" b="0">
+                <a:solidFill>
+                  <a:srgbClr val="5C564C"/>
+                </a:solidFill>
+                <a:latin typeface="Calibri"/>
+              </a:rPr>
+              <a:t>active_subscriptions    main.cs.churn_monthly</a:t>
+            </a:r>
+          </a:p>
+        </p:txBody>
+      </p:sp>
+      <p:sp>
+        <p:nvSpPr>
+          <p:cNvPr id="16" name="Rectangle 15"/>
+          <p:cNvSpPr/>
+          <p:nvPr/>
+        </p:nvSpPr>
+        <p:spPr>
+          <a:xfrm>
+            <a:off x="566928" y="4517136"/>
+            <a:ext cx="11058144" cy="9144"/>
+          </a:xfrm>
+          <a:prstGeom prst="rect">
+            <a:avLst/>
+          </a:prstGeom>
+          <a:solidFill>
+            <a:srgbClr val="E3DCD0"/>
+          </a:solidFill>
+          <a:ln>
+            <a:noFill/>
+          </a:ln>
+        </p:spPr>
+        <p:style>
+          <a:lnRef idx="1">
+            <a:schemeClr val="accent1"/>
+          </a:lnRef>
+          <a:fillRef idx="3">
+            <a:schemeClr val="accent1"/>
+          </a:fillRef>
+          <a:effectRef idx="2">
+            <a:schemeClr val="accent1"/>
+          </a:effectRef>
+          <a:fontRef idx="minor">
+            <a:schemeClr val="lt1"/>
+          </a:fontRef>
+        </p:style>
+        <p:txBody>
+          <a:bodyPr rtlCol="0" anchor="ctr"/>
+          <a:lstStyle/>
+          <a:p>
+            <a:pPr algn="ctr"/>
+          </a:p>
+        </p:txBody>
+      </p:sp>
+      <p:sp>
+        <p:nvSpPr>
+          <p:cNvPr id="17" name="TextBox 16"/>
+          <p:cNvSpPr txBox="1"/>
+          <p:nvPr/>
+        </p:nvSpPr>
+        <p:spPr>
+          <a:xfrm>
+            <a:off x="566928" y="3794760"/>
+            <a:ext cx="914400" cy="704088"/>
+          </a:xfrm>
+          <a:prstGeom prst="rect">
+            <a:avLst/>
+          </a:prstGeom>
+          <a:noFill/>
+        </p:spPr>
+        <p:txBody>
+          <a:bodyPr wrap="square" lIns="0" rIns="0" tIns="0" bIns="0" anchor="ctr"/>
+          <a:lstStyle/>
+          <a:p>
+            <a:pPr algn="l">
+              <a:lnSpc>
+                <a:spcPct val="100000"/>
+              </a:lnSpc>
+              <a:spcBef>
+                <a:spcPts val="0"/>
+              </a:spcBef>
+              <a:spcAft>
+                <a:spcPts val="0"/>
+              </a:spcAft>
+            </a:pPr>
+            <a:r>
+              <a:rPr sz="1500" b="0">
+                <a:solidFill>
+                  <a:srgbClr val="9C4221"/>
+                </a:solidFill>
+                <a:latin typeface="Georgia"/>
+              </a:rPr>
+              <a:t>f4 ·</a:t>
+            </a:r>
+          </a:p>
+        </p:txBody>
+      </p:sp>
+      <p:sp>
+        <p:nvSpPr>
+          <p:cNvPr id="18" name="TextBox 17"/>
+          <p:cNvSpPr txBox="1"/>
+          <p:nvPr/>
+        </p:nvSpPr>
+        <p:spPr>
+          <a:xfrm>
+            <a:off x="1572768" y="3794760"/>
+            <a:ext cx="3980931" cy="704088"/>
+          </a:xfrm>
+          <a:prstGeom prst="rect">
+            <a:avLst/>
+          </a:prstGeom>
+          <a:noFill/>
+        </p:spPr>
+        <p:txBody>
+          <a:bodyPr wrap="square" lIns="0" rIns="0" tIns="0" bIns="0" anchor="ctr"/>
+          <a:lstStyle/>
+          <a:p>
+            <a:pPr algn="l">
+              <a:lnSpc>
+                <a:spcPct val="100000"/>
+              </a:lnSpc>
+              <a:spcBef>
+                <a:spcPts val="0"/>
+              </a:spcBef>
+              <a:spcAft>
+                <a:spcPts val="0"/>
+              </a:spcAft>
+            </a:pPr>
+            <a:r>
+              <a:rPr sz="1500" b="0">
+                <a:solidFill>
+                  <a:srgbClr val="1C1915"/>
+                </a:solidFill>
+                <a:latin typeface="Calibri"/>
+              </a:rPr>
+              <a:t>Monthly churn</a:t>
+            </a:r>
+          </a:p>
+        </p:txBody>
+      </p:sp>
+      <p:sp>
+        <p:nvSpPr>
+          <p:cNvPr id="19" name="TextBox 18"/>
+          <p:cNvSpPr txBox="1"/>
+          <p:nvPr/>
+        </p:nvSpPr>
+        <p:spPr>
+          <a:xfrm>
+            <a:off x="5553699" y="3794760"/>
+            <a:ext cx="6071373" cy="704088"/>
+          </a:xfrm>
+          <a:prstGeom prst="rect">
+            <a:avLst/>
+          </a:prstGeom>
+          <a:noFill/>
+        </p:spPr>
+        <p:txBody>
+          <a:bodyPr wrap="square" lIns="0" rIns="0" tIns="0" bIns="0" anchor="ctr"/>
+          <a:lstStyle/>
+          <a:p>
+            <a:pPr algn="l">
+              <a:lnSpc>
+                <a:spcPct val="100000"/>
+              </a:lnSpc>
+              <a:spcBef>
+                <a:spcPts val="0"/>
+              </a:spcBef>
+              <a:spcAft>
+                <a:spcPts val="0"/>
+              </a:spcAft>
+            </a:pPr>
+            <a:r>
+              <a:rPr sz="1300" b="0">
+                <a:solidFill>
+                  <a:srgbClr val="5C564C"/>
+                </a:solidFill>
+                <a:latin typeface="Calibri"/>
+              </a:rPr>
+              <a:t>churn_trend_monthly    main.cs.churn_monthly</a:t>
+            </a:r>
+          </a:p>
+        </p:txBody>
+      </p:sp>
+      <p:sp>
+        <p:nvSpPr>
+          <p:cNvPr id="20" name="Rectangle 19"/>
+          <p:cNvSpPr/>
+          <p:nvPr/>
+        </p:nvSpPr>
+        <p:spPr>
+          <a:xfrm>
+            <a:off x="566928" y="5248656"/>
+            <a:ext cx="11058144" cy="9144"/>
+          </a:xfrm>
+          <a:prstGeom prst="rect">
+            <a:avLst/>
+          </a:prstGeom>
+          <a:solidFill>
+            <a:srgbClr val="E3DCD0"/>
+          </a:solidFill>
+          <a:ln>
+            <a:noFill/>
+          </a:ln>
+        </p:spPr>
+        <p:style>
+          <a:lnRef idx="1">
+            <a:schemeClr val="accent1"/>
+          </a:lnRef>
+          <a:fillRef idx="3">
+            <a:schemeClr val="accent1"/>
+          </a:fillRef>
+          <a:effectRef idx="2">
+            <a:schemeClr val="accent1"/>
+          </a:effectRef>
+          <a:fontRef idx="minor">
+            <a:schemeClr val="lt1"/>
+          </a:fontRef>
+        </p:style>
+        <p:txBody>
+          <a:bodyPr rtlCol="0" anchor="ctr"/>
+          <a:lstStyle/>
+          <a:p>
+            <a:pPr algn="ctr"/>
+          </a:p>
+        </p:txBody>
+      </p:sp>
+      <p:sp>
+        <p:nvSpPr>
+          <p:cNvPr id="21" name="TextBox 20"/>
+          <p:cNvSpPr txBox="1"/>
+          <p:nvPr/>
+        </p:nvSpPr>
+        <p:spPr>
+          <a:xfrm>
+            <a:off x="566928" y="4526280"/>
+            <a:ext cx="914400" cy="704088"/>
+          </a:xfrm>
+          <a:prstGeom prst="rect">
+            <a:avLst/>
+          </a:prstGeom>
+          <a:noFill/>
+        </p:spPr>
+        <p:txBody>
+          <a:bodyPr wrap="square" lIns="0" rIns="0" tIns="0" bIns="0" anchor="ctr"/>
+          <a:lstStyle/>
+          <a:p>
+            <a:pPr algn="l">
+              <a:lnSpc>
+                <a:spcPct val="100000"/>
+              </a:lnSpc>
+              <a:spcBef>
+                <a:spcPts val="0"/>
+              </a:spcBef>
+              <a:spcAft>
+                <a:spcPts val="0"/>
+              </a:spcAft>
+            </a:pPr>
+            <a:r>
+              <a:rPr sz="1500" b="0">
+                <a:solidFill>
+                  <a:srgbClr val="9C4221"/>
+                </a:solidFill>
+                <a:latin typeface="Georgia"/>
+              </a:rPr>
+              <a:t>f5 ·</a:t>
+            </a:r>
+          </a:p>
+        </p:txBody>
+      </p:sp>
+      <p:sp>
+        <p:nvSpPr>
+          <p:cNvPr id="22" name="TextBox 21"/>
+          <p:cNvSpPr txBox="1"/>
+          <p:nvPr/>
+        </p:nvSpPr>
+        <p:spPr>
+          <a:xfrm>
+            <a:off x="1572768" y="4526280"/>
+            <a:ext cx="3980931" cy="704088"/>
+          </a:xfrm>
+          <a:prstGeom prst="rect">
+            <a:avLst/>
+          </a:prstGeom>
+          <a:noFill/>
+        </p:spPr>
+        <p:txBody>
+          <a:bodyPr wrap="square" lIns="0" rIns="0" tIns="0" bIns="0" anchor="ctr"/>
+          <a:lstStyle/>
+          <a:p>
+            <a:pPr algn="l">
+              <a:lnSpc>
+                <a:spcPct val="100000"/>
+              </a:lnSpc>
+              <a:spcBef>
+                <a:spcPts val="0"/>
+              </a:spcBef>
+              <a:spcAft>
+                <a:spcPts val="0"/>
+              </a:spcAft>
+            </a:pPr>
+            <a:r>
+              <a:rPr sz="1500" b="0">
+                <a:solidFill>
+                  <a:srgbClr val="1C1915"/>
+                </a:solidFill>
+                <a:latin typeface="Calibri"/>
+              </a:rPr>
+              <a:t>Weighted monthly churn by segment</a:t>
+            </a:r>
+          </a:p>
+        </p:txBody>
+      </p:sp>
+      <p:sp>
+        <p:nvSpPr>
+          <p:cNvPr id="23" name="TextBox 22"/>
+          <p:cNvSpPr txBox="1"/>
+          <p:nvPr/>
+        </p:nvSpPr>
+        <p:spPr>
+          <a:xfrm>
+            <a:off x="5553699" y="4526280"/>
+            <a:ext cx="6071373" cy="704088"/>
+          </a:xfrm>
+          <a:prstGeom prst="rect">
+            <a:avLst/>
+          </a:prstGeom>
+          <a:noFill/>
+        </p:spPr>
+        <p:txBody>
+          <a:bodyPr wrap="square" lIns="0" rIns="0" tIns="0" bIns="0" anchor="ctr"/>
+          <a:lstStyle/>
+          <a:p>
+            <a:pPr algn="l">
+              <a:lnSpc>
+                <a:spcPct val="100000"/>
+              </a:lnSpc>
+              <a:spcBef>
+                <a:spcPts val="0"/>
+              </a:spcBef>
+              <a:spcAft>
+                <a:spcPts val="0"/>
+              </a:spcAft>
+            </a:pPr>
+            <a:r>
+              <a:rPr sz="1300" b="0">
+                <a:solidFill>
+                  <a:srgbClr val="5C564C"/>
+                </a:solidFill>
+                <a:latin typeface="Calibri"/>
+              </a:rPr>
+              <a:t>churn_by_segment    main.cs.churn_monthly</a:t>
+            </a:r>
+          </a:p>
+        </p:txBody>
+      </p:sp>
+      <p:sp>
+        <p:nvSpPr>
+          <p:cNvPr id="24" name="Rectangle 23"/>
+          <p:cNvSpPr/>
+          <p:nvPr/>
+        </p:nvSpPr>
+        <p:spPr>
+          <a:xfrm>
+            <a:off x="566928" y="6437376"/>
+            <a:ext cx="11058144" cy="9144"/>
+          </a:xfrm>
+          <a:prstGeom prst="rect">
+            <a:avLst/>
+          </a:prstGeom>
+          <a:solidFill>
+            <a:srgbClr val="E3DCD0"/>
+          </a:solidFill>
+          <a:ln>
+            <a:noFill/>
+          </a:ln>
+        </p:spPr>
+        <p:style>
+          <a:lnRef idx="1">
+            <a:schemeClr val="accent1"/>
+          </a:lnRef>
+          <a:fillRef idx="3">
+            <a:schemeClr val="accent1"/>
+          </a:fillRef>
+          <a:effectRef idx="2">
+            <a:schemeClr val="accent1"/>
+          </a:effectRef>
+          <a:fontRef idx="minor">
+            <a:schemeClr val="lt1"/>
+          </a:fontRef>
+        </p:style>
+        <p:txBody>
+          <a:bodyPr rtlCol="0" anchor="ctr"/>
+          <a:lstStyle/>
+          <a:p>
+            <a:pPr algn="ctr"/>
+          </a:p>
+        </p:txBody>
+      </p:sp>
+      <p:sp>
+        <p:nvSpPr>
+          <p:cNvPr id="25" name="TextBox 24"/>
+          <p:cNvSpPr txBox="1"/>
+          <p:nvPr/>
+        </p:nvSpPr>
+        <p:spPr>
+          <a:xfrm>
+            <a:off x="10984992" y="6483096"/>
+            <a:ext cx="640080" cy="292608"/>
+          </a:xfrm>
+          <a:prstGeom prst="rect">
+            <a:avLst/>
+          </a:prstGeom>
+          <a:noFill/>
+        </p:spPr>
+        <p:txBody>
+          <a:bodyPr wrap="square" lIns="0" rIns="0" tIns="0" bIns="0" anchor="ctr"/>
+          <a:lstStyle/>
+          <a:p>
+            <a:pPr algn="r">
+              <a:lnSpc>
+                <a:spcPct val="100000"/>
+              </a:lnSpc>
+              <a:spcBef>
+                <a:spcPts val="0"/>
+              </a:spcBef>
+              <a:spcAft>
+                <a:spcPts val="0"/>
+              </a:spcAft>
+            </a:pPr>
+            <a:r>
+              <a:rPr sz="1300" b="0">
+                <a:solidFill>
+                  <a:srgbClr val="1C1915"/>
+                </a:solidFill>
+                <a:latin typeface="Georgia"/>
+              </a:rPr>
+              <a:t>V</a:t>
             </a:r>
           </a:p>
         </p:txBody>

</xml_diff>

<commit_message>
feat: distinguish the three themes and fill the consulting layouts
Month axes use short names, the last line label sits clear of the marker, and each theme has its own cover. Table, sparkline and three-takeaway slides stay tied to fact references.

Co-authored-by: Santosh Shinde <santoshshinde2012@gmail.com>
</commit_message>
<xml_diff>
--- a/docs/examples/sample-deck.pptx
+++ b/docs/examples/sample-deck.pptx
@@ -210,6 +210,7 @@
                   </a:pPr>
                 </a:p>
               </c:txPr>
+              <c:dLblPos val="r"/>
               <c:showLegendKey val="0"/>
               <c:showVal val="1"/>
               <c:showCatName val="0"/>
@@ -258,6 +259,7 @@
                   </a:pPr>
                 </a:p>
               </c:txPr>
+              <c:dLblPos val="l"/>
               <c:showLegendKey val="0"/>
               <c:showVal val="1"/>
               <c:showCatName val="0"/>
@@ -279,13 +281,13 @@
               <c:strCache>
                 <c:ptCount val="3"/>
                 <c:pt idx="0">
-                  <c:v>2026-07</c:v>
+                  <c:v>Jul</c:v>
                 </c:pt>
                 <c:pt idx="1">
-                  <c:v>2026-08</c:v>
+                  <c:v>Aug</c:v>
                 </c:pt>
                 <c:pt idx="2">
-                  <c:v>2026-09</c:v>
+                  <c:v>Sep</c:v>
                 </c:pt>
               </c:strCache>
             </c:strRef>
@@ -381,8 +383,8 @@
       <c:valAx>
         <c:axId val="2140495176"/>
         <c:scaling>
-          <c:max val="0.02562734479891802"/>
-          <c:min val="0.021401826564709563"/>
+          <c:max val="0.025838620710628445"/>
+          <c:min val="0.02055672291786787"/>
         </c:scaling>
         <c:delete/>
         <c:axPos val="l"/>
@@ -1170,17 +1172,22 @@
           <a:lstStyle/>
           <a:p>
             <a:r>
-              <a:t>f1 · Monthly churn (weighted) · churn_rate_quarter · main.cs.churn_monthly · statement duckdb-340e134303f9 · queried 2026-10-18 07:24 UTC</a:t>
-            </a:r>
-          </a:p>
-          <a:p>
-            <a:r>
-              <a:t>f2 · Monthly NRR (weighted) · nrr_quarter · main.cs.revenue_monthly · statement duckdb-b591257632fc · queried 2026-10-18 07:24 UTC</a:t>
-            </a:r>
-          </a:p>
-          <a:p>
-            <a:r>
-              <a:t>f3 · Active subscriptions · active_subscriptions · main.cs.churn_monthly · statement duckdb-e8b898c41384 · queried 2026-10-18 07:24 UTC</a:t>
+              <a:t>f1 · Monthly churn (weighted) · churn_rate_quarter · main.cs.churn_monthly · statement duckdb-2d0b066a031a · queried 2026-10-18 07:41 UTC</a:t>
+            </a:r>
+          </a:p>
+          <a:p>
+            <a:r>
+              <a:t>f2 · Monthly NRR (weighted) · nrr_quarter · main.cs.revenue_monthly · statement duckdb-155de445a62c · queried 2026-10-18 07:41 UTC</a:t>
+            </a:r>
+          </a:p>
+          <a:p>
+            <a:r>
+              <a:t>f3 · Active subscriptions · active_subscriptions · main.cs.churn_monthly · statement duckdb-a81513bbd28d · queried 2026-10-18 07:41 UTC</a:t>
+            </a:r>
+          </a:p>
+          <a:p>
+            <a:r>
+              <a:t>f4 · Monthly churn · churn_trend_monthly · main.cs.churn_monthly · statement duckdb-8a32313abbf5 · queried 2026-10-18 07:41 UTC</a:t>
             </a:r>
           </a:p>
           <a:p>
@@ -1241,6 +1248,26 @@
           <a:p>
             <a:r>
               <a:t>f3 template SHA-256: 0e1eca481a61ce5a487969e9b73097141164bf4d00f5b0c10955808376a6caaf</a:t>
+            </a:r>
+          </a:p>
+          <a:p>
+            <a:r>
+              <a:t>f4 SQL:</a:t>
+            </a:r>
+          </a:p>
+          <a:p>
+            <a:r>
+              <a:t>SELECT STRFTIME(CAST("month" AS TIMESTAMP), '%Y-%m') AS period, CASE WHEN SUM(active_start) &lt;&gt; 0 THEN SUM(churned) / SUM(active_start) ELSE NULL END AS churn_rate FROM lake.cs.v_churn_monthly__bob WHERE "month" &gt;= $start_month AND "month" &lt; $end_month GROUP BY STRFTIME(CAST("month" AS TIMESTAMP), '%Y-%m') ORDER BY period NULLS FIRST</a:t>
+            </a:r>
+          </a:p>
+          <a:p>
+            <a:r>
+              <a:t>f4 parameters: {"end_month": "2026-10-01", "start_month": "2026-07-01"}</a:t>
+            </a:r>
+          </a:p>
+          <a:p>
+            <a:r>
+              <a:t>f4 template SHA-256: a65c9afc5de386b7fa7a0a0e07559acc0c0782b68368b4788443dcc983561b89</a:t>
             </a:r>
           </a:p>
         </p:txBody>
@@ -1310,7 +1337,7 @@
           <a:lstStyle/>
           <a:p>
             <a:r>
-              <a:t>f4 · Monthly churn · churn_trend_monthly · main.cs.churn_monthly · statement duckdb-a0f80dfe22cb · queried 2026-10-18 07:24 UTC</a:t>
+              <a:t>f4 · Monthly churn · churn_trend_monthly · main.cs.churn_monthly · statement duckdb-8a32313abbf5 · queried 2026-10-18 07:41 UTC</a:t>
             </a:r>
           </a:p>
           <a:p>
@@ -1400,7 +1427,7 @@
           <a:lstStyle/>
           <a:p>
             <a:r>
-              <a:t>f5 · Weighted monthly churn by segment · churn_by_segment · main.cs.churn_monthly · statement duckdb-1b44996c3695 · queried 2026-10-18 07:24 UTC</a:t>
+              <a:t>f5 · Weighted monthly churn by segment · churn_by_segment · main.cs.churn_monthly · statement duckdb-2a5b138f207b · queried 2026-10-18 07:41 UTC</a:t>
             </a:r>
           </a:p>
           <a:p>
@@ -1490,27 +1517,27 @@
           <a:lstStyle/>
           <a:p>
             <a:r>
-              <a:t>f1 · Monthly churn (weighted) · churn_rate_quarter · main.cs.churn_monthly · statement duckdb-340e134303f9 · queried 2026-10-18 07:24 UTC</a:t>
-            </a:r>
-          </a:p>
-          <a:p>
-            <a:r>
-              <a:t>f2 · Monthly NRR (weighted) · nrr_quarter · main.cs.revenue_monthly · statement duckdb-b591257632fc · queried 2026-10-18 07:24 UTC</a:t>
-            </a:r>
-          </a:p>
-          <a:p>
-            <a:r>
-              <a:t>f3 · Active subscriptions · active_subscriptions · main.cs.churn_monthly · statement duckdb-e8b898c41384 · queried 2026-10-18 07:24 UTC</a:t>
-            </a:r>
-          </a:p>
-          <a:p>
-            <a:r>
-              <a:t>f4 · Monthly churn · churn_trend_monthly · main.cs.churn_monthly · statement duckdb-a0f80dfe22cb · queried 2026-10-18 07:24 UTC</a:t>
-            </a:r>
-          </a:p>
-          <a:p>
-            <a:r>
-              <a:t>f5 · Weighted monthly churn by segment · churn_by_segment · main.cs.churn_monthly · statement duckdb-1b44996c3695 · queried 2026-10-18 07:24 UTC</a:t>
+              <a:t>f1 · Monthly churn (weighted) · churn_rate_quarter · main.cs.churn_monthly · statement duckdb-2d0b066a031a · queried 2026-10-18 07:41 UTC</a:t>
+            </a:r>
+          </a:p>
+          <a:p>
+            <a:r>
+              <a:t>f2 · Monthly NRR (weighted) · nrr_quarter · main.cs.revenue_monthly · statement duckdb-155de445a62c · queried 2026-10-18 07:41 UTC</a:t>
+            </a:r>
+          </a:p>
+          <a:p>
+            <a:r>
+              <a:t>f3 · Active subscriptions · active_subscriptions · main.cs.churn_monthly · statement duckdb-a81513bbd28d · queried 2026-10-18 07:41 UTC</a:t>
+            </a:r>
+          </a:p>
+          <a:p>
+            <a:r>
+              <a:t>f4 · Monthly churn · churn_trend_monthly · main.cs.churn_monthly · statement duckdb-8a32313abbf5 · queried 2026-10-18 07:41 UTC</a:t>
+            </a:r>
+          </a:p>
+          <a:p>
+            <a:r>
+              <a:t>f5 · Weighted monthly churn by segment · churn_by_segment · main.cs.churn_monthly · statement duckdb-2a5b138f207b · queried 2026-10-18 07:41 UTC</a:t>
             </a:r>
           </a:p>
           <a:p>
@@ -4632,8 +4659,8 @@
         </p:nvSpPr>
         <p:spPr>
           <a:xfrm>
-            <a:off x="7071359" y="0"/>
-            <a:ext cx="5120641" cy="6858000"/>
+            <a:off x="6827520" y="0"/>
+            <a:ext cx="5364480" cy="6858000"/>
           </a:xfrm>
           <a:prstGeom prst="rect">
             <a:avLst/>
@@ -4675,8 +4702,8 @@
         </p:nvSpPr>
         <p:spPr>
           <a:xfrm>
-            <a:off x="7016495" y="0"/>
-            <a:ext cx="54864" cy="6858000"/>
+            <a:off x="6781800" y="0"/>
+            <a:ext cx="45720" cy="6858000"/>
           </a:xfrm>
           <a:prstGeom prst="rect">
             <a:avLst/>
@@ -4712,14 +4739,272 @@
       </p:sp>
       <p:sp>
         <p:nvSpPr>
-          <p:cNvPr id="4" name="TextBox 3"/>
+          <p:cNvPr id="4" name="Rectangle 3"/>
+          <p:cNvSpPr/>
+          <p:nvPr/>
+        </p:nvSpPr>
+        <p:spPr>
+          <a:xfrm>
+            <a:off x="7467600" y="5824728"/>
+            <a:ext cx="457200" cy="576072"/>
+          </a:xfrm>
+          <a:prstGeom prst="rect">
+            <a:avLst/>
+          </a:prstGeom>
+          <a:solidFill>
+            <a:srgbClr val="9C4221"/>
+          </a:solidFill>
+          <a:ln>
+            <a:noFill/>
+          </a:ln>
+        </p:spPr>
+        <p:style>
+          <a:lnRef idx="1">
+            <a:schemeClr val="accent1"/>
+          </a:lnRef>
+          <a:fillRef idx="3">
+            <a:schemeClr val="accent1"/>
+          </a:fillRef>
+          <a:effectRef idx="2">
+            <a:schemeClr val="accent1"/>
+          </a:effectRef>
+          <a:fontRef idx="minor">
+            <a:schemeClr val="lt1"/>
+          </a:fontRef>
+        </p:style>
+        <p:txBody>
+          <a:bodyPr rtlCol="0" anchor="ctr"/>
+          <a:lstStyle/>
+          <a:p>
+            <a:pPr algn="ctr"/>
+          </a:p>
+        </p:txBody>
+      </p:sp>
+      <p:sp>
+        <p:nvSpPr>
+          <p:cNvPr id="5" name="Rectangle 4"/>
+          <p:cNvSpPr/>
+          <p:nvPr/>
+        </p:nvSpPr>
+        <p:spPr>
+          <a:xfrm>
+            <a:off x="7979664" y="5479085"/>
+            <a:ext cx="457200" cy="921715"/>
+          </a:xfrm>
+          <a:prstGeom prst="rect">
+            <a:avLst/>
+          </a:prstGeom>
+          <a:solidFill>
+            <a:srgbClr val="1A3144"/>
+          </a:solidFill>
+          <a:ln>
+            <a:noFill/>
+          </a:ln>
+        </p:spPr>
+        <p:style>
+          <a:lnRef idx="1">
+            <a:schemeClr val="accent1"/>
+          </a:lnRef>
+          <a:fillRef idx="3">
+            <a:schemeClr val="accent1"/>
+          </a:fillRef>
+          <a:effectRef idx="2">
+            <a:schemeClr val="accent1"/>
+          </a:effectRef>
+          <a:fontRef idx="minor">
+            <a:schemeClr val="lt1"/>
+          </a:fontRef>
+        </p:style>
+        <p:txBody>
+          <a:bodyPr rtlCol="0" anchor="ctr"/>
+          <a:lstStyle/>
+          <a:p>
+            <a:pPr algn="ctr"/>
+          </a:p>
+        </p:txBody>
+      </p:sp>
+      <p:sp>
+        <p:nvSpPr>
+          <p:cNvPr id="6" name="Rectangle 5"/>
+          <p:cNvSpPr/>
+          <p:nvPr/>
+        </p:nvSpPr>
+        <p:spPr>
+          <a:xfrm>
+            <a:off x="8491728" y="5914340"/>
+            <a:ext cx="457200" cy="486460"/>
+          </a:xfrm>
+          <a:prstGeom prst="rect">
+            <a:avLst/>
+          </a:prstGeom>
+          <a:solidFill>
+            <a:srgbClr val="3E6A74"/>
+          </a:solidFill>
+          <a:ln>
+            <a:noFill/>
+          </a:ln>
+        </p:spPr>
+        <p:style>
+          <a:lnRef idx="1">
+            <a:schemeClr val="accent1"/>
+          </a:lnRef>
+          <a:fillRef idx="3">
+            <a:schemeClr val="accent1"/>
+          </a:fillRef>
+          <a:effectRef idx="2">
+            <a:schemeClr val="accent1"/>
+          </a:effectRef>
+          <a:fontRef idx="minor">
+            <a:schemeClr val="lt1"/>
+          </a:fontRef>
+        </p:style>
+        <p:txBody>
+          <a:bodyPr rtlCol="0" anchor="ctr"/>
+          <a:lstStyle/>
+          <a:p>
+            <a:pPr algn="ctr"/>
+          </a:p>
+        </p:txBody>
+      </p:sp>
+      <p:sp>
+        <p:nvSpPr>
+          <p:cNvPr id="7" name="Rectangle 6"/>
+          <p:cNvSpPr/>
+          <p:nvPr/>
+        </p:nvSpPr>
+        <p:spPr>
+          <a:xfrm>
+            <a:off x="9003792" y="5248656"/>
+            <a:ext cx="457200" cy="1152144"/>
+          </a:xfrm>
+          <a:prstGeom prst="rect">
+            <a:avLst/>
+          </a:prstGeom>
+          <a:solidFill>
+            <a:srgbClr val="9C4221"/>
+          </a:solidFill>
+          <a:ln>
+            <a:noFill/>
+          </a:ln>
+        </p:spPr>
+        <p:style>
+          <a:lnRef idx="1">
+            <a:schemeClr val="accent1"/>
+          </a:lnRef>
+          <a:fillRef idx="3">
+            <a:schemeClr val="accent1"/>
+          </a:fillRef>
+          <a:effectRef idx="2">
+            <a:schemeClr val="accent1"/>
+          </a:effectRef>
+          <a:fontRef idx="minor">
+            <a:schemeClr val="lt1"/>
+          </a:fontRef>
+        </p:style>
+        <p:txBody>
+          <a:bodyPr rtlCol="0" anchor="ctr"/>
+          <a:lstStyle/>
+          <a:p>
+            <a:pPr algn="ctr"/>
+          </a:p>
+        </p:txBody>
+      </p:sp>
+      <p:sp>
+        <p:nvSpPr>
+          <p:cNvPr id="8" name="Rectangle 7"/>
+          <p:cNvSpPr/>
+          <p:nvPr/>
+        </p:nvSpPr>
+        <p:spPr>
+          <a:xfrm>
+            <a:off x="9515856" y="5658308"/>
+            <a:ext cx="457200" cy="742492"/>
+          </a:xfrm>
+          <a:prstGeom prst="rect">
+            <a:avLst/>
+          </a:prstGeom>
+          <a:solidFill>
+            <a:srgbClr val="1A3144"/>
+          </a:solidFill>
+          <a:ln>
+            <a:noFill/>
+          </a:ln>
+        </p:spPr>
+        <p:style>
+          <a:lnRef idx="1">
+            <a:schemeClr val="accent1"/>
+          </a:lnRef>
+          <a:fillRef idx="3">
+            <a:schemeClr val="accent1"/>
+          </a:fillRef>
+          <a:effectRef idx="2">
+            <a:schemeClr val="accent1"/>
+          </a:effectRef>
+          <a:fontRef idx="minor">
+            <a:schemeClr val="lt1"/>
+          </a:fontRef>
+        </p:style>
+        <p:txBody>
+          <a:bodyPr rtlCol="0" anchor="ctr"/>
+          <a:lstStyle/>
+          <a:p>
+            <a:pPr algn="ctr"/>
+          </a:p>
+        </p:txBody>
+      </p:sp>
+      <p:sp>
+        <p:nvSpPr>
+          <p:cNvPr id="9" name="Rectangle 8"/>
+          <p:cNvSpPr/>
+          <p:nvPr/>
+        </p:nvSpPr>
+        <p:spPr>
+          <a:xfrm>
+            <a:off x="10027920" y="5376672"/>
+            <a:ext cx="457200" cy="1024128"/>
+          </a:xfrm>
+          <a:prstGeom prst="rect">
+            <a:avLst/>
+          </a:prstGeom>
+          <a:solidFill>
+            <a:srgbClr val="3E6A74"/>
+          </a:solidFill>
+          <a:ln>
+            <a:noFill/>
+          </a:ln>
+        </p:spPr>
+        <p:style>
+          <a:lnRef idx="1">
+            <a:schemeClr val="accent1"/>
+          </a:lnRef>
+          <a:fillRef idx="3">
+            <a:schemeClr val="accent1"/>
+          </a:fillRef>
+          <a:effectRef idx="2">
+            <a:schemeClr val="accent1"/>
+          </a:effectRef>
+          <a:fontRef idx="minor">
+            <a:schemeClr val="lt1"/>
+          </a:fontRef>
+        </p:style>
+        <p:txBody>
+          <a:bodyPr rtlCol="0" anchor="ctr"/>
+          <a:lstStyle/>
+          <a:p>
+            <a:pPr algn="ctr"/>
+          </a:p>
+        </p:txBody>
+      </p:sp>
+      <p:sp>
+        <p:nvSpPr>
+          <p:cNvPr id="10" name="TextBox 9"/>
           <p:cNvSpPr txBox="1"/>
           <p:nvPr/>
         </p:nvSpPr>
         <p:spPr>
           <a:xfrm>
-            <a:off x="566928" y="6035040"/>
-            <a:ext cx="1828800" cy="274320"/>
+            <a:off x="566928" y="1920240"/>
+            <a:ext cx="6077712" cy="2011680"/>
           </a:xfrm>
           <a:prstGeom prst="rect">
             <a:avLst/>
@@ -4742,36 +5027,15 @@
               </a:spcAft>
             </a:pPr>
             <a:r>
-              <a:rPr sz="1200" b="0">
+              <a:rPr sz="4400" b="0">
                 <a:solidFill>
-                  <a:srgbClr val="C5D0D6"/>
+                  <a:srgbClr val="F4F0E8"/>
                 </a:solidFill>
-                <a:latin typeface="Calibri"/>
+                <a:latin typeface="Georgia"/>
               </a:rPr>
-              <a:t>DeckSmith</a:t>
-            </a:r>
-          </a:p>
-        </p:txBody>
-      </p:sp>
-      <p:sp>
-        <p:nvSpPr>
-          <p:cNvPr id="5" name="TextBox 4"/>
-          <p:cNvSpPr txBox="1"/>
-          <p:nvPr/>
-        </p:nvSpPr>
-        <p:spPr>
-          <a:xfrm>
-            <a:off x="566928" y="2057400"/>
-            <a:ext cx="6367271" cy="2011680"/>
-          </a:xfrm>
-          <a:prstGeom prst="rect">
-            <a:avLst/>
-          </a:prstGeom>
-          <a:noFill/>
-        </p:spPr>
-        <p:txBody>
-          <a:bodyPr wrap="square" lIns="0" rIns="0" tIns="0" bIns="0" anchor="t"/>
-          <a:lstStyle/>
+              <a:t>Customer retention</a:t>
+            </a:r>
+          </a:p>
           <a:p>
             <a:pPr algn="l">
               <a:lnSpc>
@@ -4791,9 +5055,30 @@
                 </a:solidFill>
                 <a:latin typeface="Georgia"/>
               </a:rPr>
-              <a:t>Customer retention</a:t>
-            </a:r>
-          </a:p>
+              <a:t>review</a:t>
+            </a:r>
+          </a:p>
+        </p:txBody>
+      </p:sp>
+      <p:sp>
+        <p:nvSpPr>
+          <p:cNvPr id="11" name="TextBox 10"/>
+          <p:cNvSpPr txBox="1"/>
+          <p:nvPr/>
+        </p:nvSpPr>
+        <p:spPr>
+          <a:xfrm>
+            <a:off x="566928" y="4023360"/>
+            <a:ext cx="6077712" cy="731520"/>
+          </a:xfrm>
+          <a:prstGeom prst="rect">
+            <a:avLst/>
+          </a:prstGeom>
+          <a:noFill/>
+        </p:spPr>
+        <p:txBody>
+          <a:bodyPr wrap="square" lIns="0" rIns="0" tIns="0" bIns="0" anchor="t"/>
+          <a:lstStyle/>
           <a:p>
             <a:pPr algn="l">
               <a:lnSpc>
@@ -4807,27 +5092,27 @@
               </a:spcAft>
             </a:pPr>
             <a:r>
-              <a:rPr sz="4400" b="0">
+              <a:rPr sz="1800" b="0">
                 <a:solidFill>
-                  <a:srgbClr val="F4F0E8"/>
+                  <a:srgbClr val="C5D0D6"/>
                 </a:solidFill>
-                <a:latin typeface="Georgia"/>
+                <a:latin typeface="Calibri"/>
               </a:rPr>
-              <a:t>review</a:t>
-            </a:r>
-          </a:p>
-        </p:txBody>
-      </p:sp>
-      <p:sp>
-        <p:nvSpPr>
-          <p:cNvPr id="6" name="TextBox 5"/>
+              <a:t>Prepared for the exec audience</a:t>
+            </a:r>
+          </a:p>
+        </p:txBody>
+      </p:sp>
+      <p:sp>
+        <p:nvSpPr>
+          <p:cNvPr id="12" name="TextBox 11"/>
           <p:cNvSpPr txBox="1"/>
           <p:nvPr/>
         </p:nvSpPr>
         <p:spPr>
           <a:xfrm>
-            <a:off x="566928" y="4160520"/>
-            <a:ext cx="6367271" cy="731520"/>
+            <a:off x="566928" y="6464808"/>
+            <a:ext cx="1828800" cy="274320"/>
           </a:xfrm>
           <a:prstGeom prst="rect">
             <a:avLst/>
@@ -4850,70 +5135,27 @@
               </a:spcAft>
             </a:pPr>
             <a:r>
-              <a:rPr sz="1800" b="0">
+              <a:rPr sz="1200" b="0">
                 <a:solidFill>
                   <a:srgbClr val="C5D0D6"/>
                 </a:solidFill>
                 <a:latin typeface="Calibri"/>
               </a:rPr>
-              <a:t>Prepared for the exec audience</a:t>
-            </a:r>
-          </a:p>
-        </p:txBody>
-      </p:sp>
-      <p:sp>
-        <p:nvSpPr>
-          <p:cNvPr id="7" name="Oval 6"/>
-          <p:cNvSpPr/>
-          <p:nvPr/>
-        </p:nvSpPr>
-        <p:spPr>
-          <a:xfrm>
-            <a:off x="8808719" y="2606040"/>
-            <a:ext cx="1645920" cy="1645920"/>
-          </a:xfrm>
-          <a:prstGeom prst="ellipse">
-            <a:avLst/>
-          </a:prstGeom>
-          <a:noFill/>
-          <a:ln w="15875">
-            <a:solidFill>
-              <a:srgbClr val="9C4221"/>
-            </a:solidFill>
-          </a:ln>
-        </p:spPr>
-        <p:style>
-          <a:lnRef idx="1">
-            <a:schemeClr val="accent1"/>
-          </a:lnRef>
-          <a:fillRef idx="3">
-            <a:schemeClr val="accent1"/>
-          </a:fillRef>
-          <a:effectRef idx="2">
-            <a:schemeClr val="accent1"/>
-          </a:effectRef>
-          <a:fontRef idx="minor">
-            <a:schemeClr val="lt1"/>
-          </a:fontRef>
-        </p:style>
-        <p:txBody>
-          <a:bodyPr rtlCol="0" anchor="ctr"/>
-          <a:lstStyle/>
-          <a:p>
-            <a:pPr algn="ctr"/>
-          </a:p>
-        </p:txBody>
-      </p:sp>
-      <p:sp>
-        <p:nvSpPr>
-          <p:cNvPr id="8" name="TextBox 7"/>
+              <a:t>DeckSmith</a:t>
+            </a:r>
+          </a:p>
+        </p:txBody>
+      </p:sp>
+      <p:sp>
+        <p:nvSpPr>
+          <p:cNvPr id="13" name="TextBox 12"/>
           <p:cNvSpPr txBox="1"/>
           <p:nvPr/>
         </p:nvSpPr>
         <p:spPr>
           <a:xfrm>
-            <a:off x="5864351" y="6483096"/>
-            <a:ext cx="640080" cy="292608"/>
+            <a:off x="5620512" y="6464808"/>
+            <a:ext cx="548640" cy="292608"/>
           </a:xfrm>
           <a:prstGeom prst="rect">
             <a:avLst/>
@@ -5067,8 +5309,8 @@
         </p:nvSpPr>
         <p:spPr>
           <a:xfrm>
-            <a:off x="566928" y="1463040"/>
-            <a:ext cx="3740912" cy="2057400"/>
+            <a:off x="566928" y="1417320"/>
+            <a:ext cx="3740912" cy="2377440"/>
           </a:xfrm>
           <a:prstGeom prst="roundRect">
             <a:avLst>
@@ -5112,7 +5354,7 @@
         </p:nvSpPr>
         <p:spPr>
           <a:xfrm>
-            <a:off x="566928" y="1463040"/>
+            <a:off x="566928" y="1417320"/>
             <a:ext cx="3740912" cy="36576"/>
           </a:xfrm>
           <a:prstGeom prst="rect">
@@ -5155,8 +5397,8 @@
         </p:nvSpPr>
         <p:spPr>
           <a:xfrm>
-            <a:off x="704088" y="1691640"/>
-            <a:ext cx="3512312" cy="822960"/>
+            <a:off x="704088" y="1554480"/>
+            <a:ext cx="3466592" cy="731520"/>
           </a:xfrm>
           <a:prstGeom prst="rect">
             <a:avLst/>
@@ -5179,7 +5421,7 @@
               </a:spcAft>
             </a:pPr>
             <a:r>
-              <a:rPr sz="4000" b="1">
+              <a:rPr sz="3600" b="1">
                 <a:solidFill>
                   <a:srgbClr val="1C1915"/>
                 </a:solidFill>
@@ -5198,8 +5440,8 @@
         </p:nvSpPr>
         <p:spPr>
           <a:xfrm>
-            <a:off x="704088" y="2560320"/>
-            <a:ext cx="3512312" cy="640080"/>
+            <a:off x="704088" y="2286000"/>
+            <a:ext cx="3466592" cy="457200"/>
           </a:xfrm>
           <a:prstGeom prst="rect">
             <a:avLst/>
@@ -5235,14 +5477,186 @@
       </p:sp>
       <p:sp>
         <p:nvSpPr>
-          <p:cNvPr id="8" name="Rounded Rectangle 7"/>
+          <p:cNvPr id="8" name="Rectangle 7"/>
           <p:cNvSpPr/>
           <p:nvPr/>
         </p:nvSpPr>
         <p:spPr>
           <a:xfrm>
-            <a:off x="4307840" y="1463040"/>
-            <a:ext cx="3740912" cy="2057400"/>
+            <a:off x="704088" y="3154680"/>
+            <a:ext cx="1001460" cy="320040"/>
+          </a:xfrm>
+          <a:prstGeom prst="rect">
+            <a:avLst/>
+          </a:prstGeom>
+          <a:solidFill>
+            <a:srgbClr val="9C4221"/>
+          </a:solidFill>
+          <a:ln>
+            <a:noFill/>
+          </a:ln>
+        </p:spPr>
+        <p:style>
+          <a:lnRef idx="1">
+            <a:schemeClr val="accent1"/>
+          </a:lnRef>
+          <a:fillRef idx="3">
+            <a:schemeClr val="accent1"/>
+          </a:fillRef>
+          <a:effectRef idx="2">
+            <a:schemeClr val="accent1"/>
+          </a:effectRef>
+          <a:fontRef idx="minor">
+            <a:schemeClr val="lt1"/>
+          </a:fontRef>
+        </p:style>
+        <p:txBody>
+          <a:bodyPr rtlCol="0" anchor="ctr"/>
+          <a:lstStyle/>
+          <a:p>
+            <a:pPr algn="ctr"/>
+          </a:p>
+        </p:txBody>
+      </p:sp>
+      <p:sp>
+        <p:nvSpPr>
+          <p:cNvPr id="9" name="Rectangle 8"/>
+          <p:cNvSpPr/>
+          <p:nvPr/>
+        </p:nvSpPr>
+        <p:spPr>
+          <a:xfrm>
+            <a:off x="1936654" y="3208778"/>
+            <a:ext cx="1001460" cy="265942"/>
+          </a:xfrm>
+          <a:prstGeom prst="rect">
+            <a:avLst/>
+          </a:prstGeom>
+          <a:solidFill>
+            <a:srgbClr val="9C4221"/>
+          </a:solidFill>
+          <a:ln>
+            <a:noFill/>
+          </a:ln>
+        </p:spPr>
+        <p:style>
+          <a:lnRef idx="1">
+            <a:schemeClr val="accent1"/>
+          </a:lnRef>
+          <a:fillRef idx="3">
+            <a:schemeClr val="accent1"/>
+          </a:fillRef>
+          <a:effectRef idx="2">
+            <a:schemeClr val="accent1"/>
+          </a:effectRef>
+          <a:fontRef idx="minor">
+            <a:schemeClr val="lt1"/>
+          </a:fontRef>
+        </p:style>
+        <p:txBody>
+          <a:bodyPr rtlCol="0" anchor="ctr"/>
+          <a:lstStyle/>
+          <a:p>
+            <a:pPr algn="ctr"/>
+          </a:p>
+        </p:txBody>
+      </p:sp>
+      <p:sp>
+        <p:nvSpPr>
+          <p:cNvPr id="10" name="Rectangle 9"/>
+          <p:cNvSpPr/>
+          <p:nvPr/>
+        </p:nvSpPr>
+        <p:spPr>
+          <a:xfrm>
+            <a:off x="3169220" y="3385109"/>
+            <a:ext cx="1001460" cy="89611"/>
+          </a:xfrm>
+          <a:prstGeom prst="rect">
+            <a:avLst/>
+          </a:prstGeom>
+          <a:solidFill>
+            <a:srgbClr val="9C4221"/>
+          </a:solidFill>
+          <a:ln>
+            <a:noFill/>
+          </a:ln>
+        </p:spPr>
+        <p:style>
+          <a:lnRef idx="1">
+            <a:schemeClr val="accent1"/>
+          </a:lnRef>
+          <a:fillRef idx="3">
+            <a:schemeClr val="accent1"/>
+          </a:fillRef>
+          <a:effectRef idx="2">
+            <a:schemeClr val="accent1"/>
+          </a:effectRef>
+          <a:fontRef idx="minor">
+            <a:schemeClr val="lt1"/>
+          </a:fontRef>
+        </p:style>
+        <p:txBody>
+          <a:bodyPr rtlCol="0" anchor="ctr"/>
+          <a:lstStyle/>
+          <a:p>
+            <a:pPr algn="ctr"/>
+          </a:p>
+        </p:txBody>
+      </p:sp>
+      <p:sp>
+        <p:nvSpPr>
+          <p:cNvPr id="11" name="TextBox 10"/>
+          <p:cNvSpPr txBox="1"/>
+          <p:nvPr/>
+        </p:nvSpPr>
+        <p:spPr>
+          <a:xfrm>
+            <a:off x="704088" y="2788920"/>
+            <a:ext cx="3466592" cy="320040"/>
+          </a:xfrm>
+          <a:prstGeom prst="rect">
+            <a:avLst/>
+          </a:prstGeom>
+          <a:noFill/>
+        </p:spPr>
+        <p:txBody>
+          <a:bodyPr wrap="square" lIns="0" rIns="0" tIns="0" bIns="0" anchor="t"/>
+          <a:lstStyle/>
+          <a:p>
+            <a:pPr algn="l">
+              <a:lnSpc>
+                <a:spcPct val="100000"/>
+              </a:lnSpc>
+              <a:spcBef>
+                <a:spcPts val="0"/>
+              </a:spcBef>
+              <a:spcAft>
+                <a:spcPts val="0"/>
+              </a:spcAft>
+            </a:pPr>
+            <a:r>
+              <a:rPr sz="1200" b="1">
+                <a:solidFill>
+                  <a:srgbClr val="9C4221"/>
+                </a:solidFill>
+                <a:latin typeface="Calibri"/>
+              </a:rPr>
+              <a:t>Ended lower</a:t>
+            </a:r>
+          </a:p>
+        </p:txBody>
+      </p:sp>
+      <p:sp>
+        <p:nvSpPr>
+          <p:cNvPr id="12" name="Rounded Rectangle 11"/>
+          <p:cNvSpPr/>
+          <p:nvPr/>
+        </p:nvSpPr>
+        <p:spPr>
+          <a:xfrm>
+            <a:off x="4307840" y="1417320"/>
+            <a:ext cx="3740912" cy="2377440"/>
           </a:xfrm>
           <a:prstGeom prst="roundRect">
             <a:avLst>
@@ -5280,13 +5694,13 @@
       </p:sp>
       <p:sp>
         <p:nvSpPr>
-          <p:cNvPr id="9" name="Rectangle 8"/>
+          <p:cNvPr id="13" name="Rectangle 12"/>
           <p:cNvSpPr/>
           <p:nvPr/>
         </p:nvSpPr>
         <p:spPr>
           <a:xfrm>
-            <a:off x="4307840" y="1463040"/>
+            <a:off x="4307840" y="1417320"/>
             <a:ext cx="3740912" cy="36576"/>
           </a:xfrm>
           <a:prstGeom prst="rect">
@@ -5323,14 +5737,14 @@
       </p:sp>
       <p:sp>
         <p:nvSpPr>
-          <p:cNvPr id="10" name="TextBox 9"/>
+          <p:cNvPr id="14" name="TextBox 13"/>
           <p:cNvSpPr txBox="1"/>
           <p:nvPr/>
         </p:nvSpPr>
         <p:spPr>
           <a:xfrm>
-            <a:off x="4445000" y="1691640"/>
-            <a:ext cx="3512312" cy="822960"/>
+            <a:off x="4445000" y="1554480"/>
+            <a:ext cx="3466592" cy="731520"/>
           </a:xfrm>
           <a:prstGeom prst="rect">
             <a:avLst/>
@@ -5353,7 +5767,7 @@
               </a:spcAft>
             </a:pPr>
             <a:r>
-              <a:rPr sz="4000" b="1">
+              <a:rPr sz="3600" b="1">
                 <a:solidFill>
                   <a:srgbClr val="1C1915"/>
                 </a:solidFill>
@@ -5366,14 +5780,14 @@
       </p:sp>
       <p:sp>
         <p:nvSpPr>
-          <p:cNvPr id="11" name="TextBox 10"/>
+          <p:cNvPr id="15" name="TextBox 14"/>
           <p:cNvSpPr txBox="1"/>
           <p:nvPr/>
         </p:nvSpPr>
         <p:spPr>
           <a:xfrm>
-            <a:off x="4445000" y="2560320"/>
-            <a:ext cx="3512312" cy="640080"/>
+            <a:off x="4445000" y="2286000"/>
+            <a:ext cx="3466592" cy="457200"/>
           </a:xfrm>
           <a:prstGeom prst="rect">
             <a:avLst/>
@@ -5409,14 +5823,14 @@
       </p:sp>
       <p:sp>
         <p:nvSpPr>
-          <p:cNvPr id="12" name="Rounded Rectangle 11"/>
+          <p:cNvPr id="16" name="Rounded Rectangle 15"/>
           <p:cNvSpPr/>
           <p:nvPr/>
         </p:nvSpPr>
         <p:spPr>
           <a:xfrm>
-            <a:off x="8048752" y="1463040"/>
-            <a:ext cx="3576320" cy="2057400"/>
+            <a:off x="8048752" y="1417320"/>
+            <a:ext cx="3576320" cy="2377440"/>
           </a:xfrm>
           <a:prstGeom prst="roundRect">
             <a:avLst>
@@ -5454,13 +5868,13 @@
       </p:sp>
       <p:sp>
         <p:nvSpPr>
-          <p:cNvPr id="13" name="Rectangle 12"/>
+          <p:cNvPr id="17" name="Rectangle 16"/>
           <p:cNvSpPr/>
           <p:nvPr/>
         </p:nvSpPr>
         <p:spPr>
           <a:xfrm>
-            <a:off x="8048752" y="1463040"/>
+            <a:off x="8048752" y="1417320"/>
             <a:ext cx="3576320" cy="36576"/>
           </a:xfrm>
           <a:prstGeom prst="rect">
@@ -5497,14 +5911,14 @@
       </p:sp>
       <p:sp>
         <p:nvSpPr>
-          <p:cNvPr id="14" name="TextBox 13"/>
+          <p:cNvPr id="18" name="TextBox 17"/>
           <p:cNvSpPr txBox="1"/>
           <p:nvPr/>
         </p:nvSpPr>
         <p:spPr>
           <a:xfrm>
-            <a:off x="8185912" y="1691640"/>
-            <a:ext cx="3347720" cy="822960"/>
+            <a:off x="8185912" y="1554480"/>
+            <a:ext cx="3302000" cy="731520"/>
           </a:xfrm>
           <a:prstGeom prst="rect">
             <a:avLst/>
@@ -5527,7 +5941,7 @@
               </a:spcAft>
             </a:pPr>
             <a:r>
-              <a:rPr sz="4000" b="1">
+              <a:rPr sz="3600" b="1">
                 <a:solidFill>
                   <a:srgbClr val="1C1915"/>
                 </a:solidFill>
@@ -5540,14 +5954,14 @@
       </p:sp>
       <p:sp>
         <p:nvSpPr>
-          <p:cNvPr id="15" name="TextBox 14"/>
+          <p:cNvPr id="19" name="TextBox 18"/>
           <p:cNvSpPr txBox="1"/>
           <p:nvPr/>
         </p:nvSpPr>
         <p:spPr>
           <a:xfrm>
-            <a:off x="8185912" y="2560320"/>
-            <a:ext cx="3347720" cy="640080"/>
+            <a:off x="8185912" y="2286000"/>
+            <a:ext cx="3302000" cy="457200"/>
           </a:xfrm>
           <a:prstGeom prst="rect">
             <a:avLst/>
@@ -5583,13 +5997,13 @@
       </p:sp>
       <p:sp>
         <p:nvSpPr>
-          <p:cNvPr id="16" name="Rounded Rectangle 15"/>
+          <p:cNvPr id="20" name="Rounded Rectangle 19"/>
           <p:cNvSpPr/>
           <p:nvPr/>
         </p:nvSpPr>
         <p:spPr>
           <a:xfrm>
-            <a:off x="566928" y="3794760"/>
+            <a:off x="566928" y="3931920"/>
             <a:ext cx="11058144" cy="1188720"/>
           </a:xfrm>
           <a:prstGeom prst="roundRect">
@@ -5628,13 +6042,13 @@
       </p:sp>
       <p:sp>
         <p:nvSpPr>
-          <p:cNvPr id="17" name="Rectangle 16"/>
+          <p:cNvPr id="21" name="Rectangle 20"/>
           <p:cNvSpPr/>
           <p:nvPr/>
         </p:nvSpPr>
         <p:spPr>
           <a:xfrm>
-            <a:off x="566928" y="3794760"/>
+            <a:off x="566928" y="3931920"/>
             <a:ext cx="54864" cy="1188720"/>
           </a:xfrm>
           <a:prstGeom prst="rect">
@@ -5671,13 +6085,13 @@
       </p:sp>
       <p:sp>
         <p:nvSpPr>
-          <p:cNvPr id="18" name="TextBox 17"/>
+          <p:cNvPr id="22" name="TextBox 21"/>
           <p:cNvSpPr txBox="1"/>
           <p:nvPr/>
         </p:nvSpPr>
         <p:spPr>
           <a:xfrm>
-            <a:off x="841248" y="3886200"/>
+            <a:off x="841248" y="4023360"/>
             <a:ext cx="10646664" cy="1005840"/>
           </a:xfrm>
           <a:prstGeom prst="rect">
@@ -5714,7 +6128,7 @@
       </p:sp>
       <p:sp>
         <p:nvSpPr>
-          <p:cNvPr id="19" name="Rectangle 18"/>
+          <p:cNvPr id="23" name="Rectangle 22"/>
           <p:cNvSpPr/>
           <p:nvPr/>
         </p:nvSpPr>
@@ -5757,7 +6171,7 @@
       </p:sp>
       <p:sp>
         <p:nvSpPr>
-          <p:cNvPr id="20" name="TextBox 19"/>
+          <p:cNvPr id="24" name="TextBox 23"/>
           <p:cNvSpPr txBox="1"/>
           <p:nvPr/>
         </p:nvSpPr>
@@ -5800,7 +6214,7 @@
       </p:sp>
       <p:sp>
         <p:nvSpPr>
-          <p:cNvPr id="21" name="TextBox 20"/>
+          <p:cNvPr id="25" name="TextBox 24"/>
           <p:cNvSpPr txBox="1"/>
           <p:nvPr/>
         </p:nvSpPr>

</xml_diff>